<commit_message>
Relatorio e apresentacao com a analise de entrega e recompra
</commit_message>
<xml_diff>
--- a/reports/apresentacao_crescimento_receita.pptx
+++ b/reports/apresentacao_crescimento_receita.pptx
@@ -21,9 +21,12 @@
     <p:sldId id="269" r:id="rId15"/>
     <p:sldId id="270" r:id="rId16"/>
     <p:sldId id="271" r:id="rId17"/>
+    <p:sldId id="272" r:id="rId18"/>
+    <p:sldId id="273" r:id="rId19"/>
+    <p:sldId id="274" r:id="rId20"/>
   </p:sldIdLst>
   <p:notesMasterIdLst>
-    <p:notesMasterId r:id="rId18"/>
+    <p:notesMasterId r:id="rId21"/>
   </p:notesMasterIdLst>
   <p:sldSz cx="12192000" cy="6858000"/>
   <p:notesSz cx="6858000" cy="12192000"/>
@@ -1157,6 +1160,270 @@
             <a:fld id="{F7021451-1387-4CA6-816F-3879F97B5CBC}" type="slidenum">
               <a:rPr lang="en-US"/>
               <a:t>16</a:t>
+            </a:fld>
+            <a:endParaRPr lang="en-US"/>
+          </a:p>
+        </p:txBody>
+      </p:sp>
+    </p:spTree>
+    <p:extLst>
+      <p:ext uri="{BB962C8B-B14F-4D97-AF65-F5344CB8AC3E}">
+        <p14:creationId xmlns:p14="http://schemas.microsoft.com/office/powerpoint/2010/main" val="1024086991"/>
+      </p:ext>
+    </p:extLst>
+  </p:cSld>
+  <p:clrMapOvr>
+    <a:masterClrMapping/>
+  </p:clrMapOvr>
+</p:notes>
+</file>
+
+<file path=ppt/notesSlides/notesSlide17.xml><?xml version="1.0" encoding="utf-8"?>
+<p:notes xmlns:a="http://schemas.openxmlformats.org/drawingml/2006/main" xmlns:r="http://schemas.openxmlformats.org/officeDocument/2006/relationships" xmlns:p="http://schemas.openxmlformats.org/presentationml/2006/main">
+  <p:cSld>
+    <p:spTree>
+      <p:nvGrpSpPr>
+        <p:cNvPr id="1" name=""/>
+        <p:cNvGrpSpPr/>
+        <p:nvPr/>
+      </p:nvGrpSpPr>
+      <p:grpSpPr>
+        <a:xfrm>
+          <a:off x="0" y="0"/>
+          <a:ext cx="0" cy="0"/>
+          <a:chOff x="0" y="0"/>
+          <a:chExt cx="0" cy="0"/>
+        </a:xfrm>
+      </p:grpSpPr>
+      <p:sp>
+        <p:nvSpPr>
+          <p:cNvPr id="2" name="Slide Image Placeholder 1"/>
+          <p:cNvSpPr>
+            <a:spLocks noGrp="1" noRot="1" noChangeAspect="1"/>
+          </p:cNvSpPr>
+          <p:nvPr>
+            <p:ph type="sldImg"/>
+          </p:nvPr>
+        </p:nvSpPr>
+        <p:spPr/>
+      </p:sp>
+      <p:sp>
+        <p:nvSpPr>
+          <p:cNvPr id="3" name="Notes Placeholder 2"/>
+          <p:cNvSpPr>
+            <a:spLocks noGrp="1"/>
+          </p:cNvSpPr>
+          <p:nvPr>
+            <p:ph type="body" idx="1"/>
+          </p:nvPr>
+        </p:nvSpPr>
+        <p:spPr/>
+        <p:txBody>
+          <a:bodyPr/>
+          <a:lstStyle/>
+          <a:p>
+            <a:r>
+              <a:rPr lang="en-US" dirty="0"/>
+              <a:t/>
+            </a:r>
+            <a:endParaRPr lang="en-US" dirty="0"/>
+          </a:p>
+        </p:txBody>
+      </p:sp>
+      <p:sp>
+        <p:nvSpPr>
+          <p:cNvPr id="4" name="Slide Number Placeholder 3"/>
+          <p:cNvSpPr>
+            <a:spLocks noGrp="1"/>
+          </p:cNvSpPr>
+          <p:nvPr>
+            <p:ph type="sldNum" sz="quarter" idx="10"/>
+          </p:nvPr>
+        </p:nvSpPr>
+        <p:spPr/>
+        <p:txBody>
+          <a:bodyPr/>
+          <a:lstStyle/>
+          <a:p>
+            <a:fld id="{F7021451-1387-4CA6-816F-3879F97B5CBC}" type="slidenum">
+              <a:rPr lang="en-US"/>
+              <a:t>17</a:t>
+            </a:fld>
+            <a:endParaRPr lang="en-US"/>
+          </a:p>
+        </p:txBody>
+      </p:sp>
+    </p:spTree>
+    <p:extLst>
+      <p:ext uri="{BB962C8B-B14F-4D97-AF65-F5344CB8AC3E}">
+        <p14:creationId xmlns:p14="http://schemas.microsoft.com/office/powerpoint/2010/main" val="1024086991"/>
+      </p:ext>
+    </p:extLst>
+  </p:cSld>
+  <p:clrMapOvr>
+    <a:masterClrMapping/>
+  </p:clrMapOvr>
+</p:notes>
+</file>
+
+<file path=ppt/notesSlides/notesSlide18.xml><?xml version="1.0" encoding="utf-8"?>
+<p:notes xmlns:a="http://schemas.openxmlformats.org/drawingml/2006/main" xmlns:r="http://schemas.openxmlformats.org/officeDocument/2006/relationships" xmlns:p="http://schemas.openxmlformats.org/presentationml/2006/main">
+  <p:cSld>
+    <p:spTree>
+      <p:nvGrpSpPr>
+        <p:cNvPr id="1" name=""/>
+        <p:cNvGrpSpPr/>
+        <p:nvPr/>
+      </p:nvGrpSpPr>
+      <p:grpSpPr>
+        <a:xfrm>
+          <a:off x="0" y="0"/>
+          <a:ext cx="0" cy="0"/>
+          <a:chOff x="0" y="0"/>
+          <a:chExt cx="0" cy="0"/>
+        </a:xfrm>
+      </p:grpSpPr>
+      <p:sp>
+        <p:nvSpPr>
+          <p:cNvPr id="2" name="Slide Image Placeholder 1"/>
+          <p:cNvSpPr>
+            <a:spLocks noGrp="1" noRot="1" noChangeAspect="1"/>
+          </p:cNvSpPr>
+          <p:nvPr>
+            <p:ph type="sldImg"/>
+          </p:nvPr>
+        </p:nvSpPr>
+        <p:spPr/>
+      </p:sp>
+      <p:sp>
+        <p:nvSpPr>
+          <p:cNvPr id="3" name="Notes Placeholder 2"/>
+          <p:cNvSpPr>
+            <a:spLocks noGrp="1"/>
+          </p:cNvSpPr>
+          <p:nvPr>
+            <p:ph type="body" idx="1"/>
+          </p:nvPr>
+        </p:nvSpPr>
+        <p:spPr/>
+        <p:txBody>
+          <a:bodyPr/>
+          <a:lstStyle/>
+          <a:p>
+            <a:r>
+              <a:rPr lang="en-US" dirty="0"/>
+              <a:t/>
+            </a:r>
+            <a:endParaRPr lang="en-US" dirty="0"/>
+          </a:p>
+        </p:txBody>
+      </p:sp>
+      <p:sp>
+        <p:nvSpPr>
+          <p:cNvPr id="4" name="Slide Number Placeholder 3"/>
+          <p:cNvSpPr>
+            <a:spLocks noGrp="1"/>
+          </p:cNvSpPr>
+          <p:nvPr>
+            <p:ph type="sldNum" sz="quarter" idx="10"/>
+          </p:nvPr>
+        </p:nvSpPr>
+        <p:spPr/>
+        <p:txBody>
+          <a:bodyPr/>
+          <a:lstStyle/>
+          <a:p>
+            <a:fld id="{F7021451-1387-4CA6-816F-3879F97B5CBC}" type="slidenum">
+              <a:rPr lang="en-US"/>
+              <a:t>18</a:t>
+            </a:fld>
+            <a:endParaRPr lang="en-US"/>
+          </a:p>
+        </p:txBody>
+      </p:sp>
+    </p:spTree>
+    <p:extLst>
+      <p:ext uri="{BB962C8B-B14F-4D97-AF65-F5344CB8AC3E}">
+        <p14:creationId xmlns:p14="http://schemas.microsoft.com/office/powerpoint/2010/main" val="1024086991"/>
+      </p:ext>
+    </p:extLst>
+  </p:cSld>
+  <p:clrMapOvr>
+    <a:masterClrMapping/>
+  </p:clrMapOvr>
+</p:notes>
+</file>
+
+<file path=ppt/notesSlides/notesSlide19.xml><?xml version="1.0" encoding="utf-8"?>
+<p:notes xmlns:a="http://schemas.openxmlformats.org/drawingml/2006/main" xmlns:r="http://schemas.openxmlformats.org/officeDocument/2006/relationships" xmlns:p="http://schemas.openxmlformats.org/presentationml/2006/main">
+  <p:cSld>
+    <p:spTree>
+      <p:nvGrpSpPr>
+        <p:cNvPr id="1" name=""/>
+        <p:cNvGrpSpPr/>
+        <p:nvPr/>
+      </p:nvGrpSpPr>
+      <p:grpSpPr>
+        <a:xfrm>
+          <a:off x="0" y="0"/>
+          <a:ext cx="0" cy="0"/>
+          <a:chOff x="0" y="0"/>
+          <a:chExt cx="0" cy="0"/>
+        </a:xfrm>
+      </p:grpSpPr>
+      <p:sp>
+        <p:nvSpPr>
+          <p:cNvPr id="2" name="Slide Image Placeholder 1"/>
+          <p:cNvSpPr>
+            <a:spLocks noGrp="1" noRot="1" noChangeAspect="1"/>
+          </p:cNvSpPr>
+          <p:nvPr>
+            <p:ph type="sldImg"/>
+          </p:nvPr>
+        </p:nvSpPr>
+        <p:spPr/>
+      </p:sp>
+      <p:sp>
+        <p:nvSpPr>
+          <p:cNvPr id="3" name="Notes Placeholder 2"/>
+          <p:cNvSpPr>
+            <a:spLocks noGrp="1"/>
+          </p:cNvSpPr>
+          <p:nvPr>
+            <p:ph type="body" idx="1"/>
+          </p:nvPr>
+        </p:nvSpPr>
+        <p:spPr/>
+        <p:txBody>
+          <a:bodyPr/>
+          <a:lstStyle/>
+          <a:p>
+            <a:r>
+              <a:rPr lang="en-US" dirty="0"/>
+              <a:t/>
+            </a:r>
+            <a:endParaRPr lang="en-US" dirty="0"/>
+          </a:p>
+        </p:txBody>
+      </p:sp>
+      <p:sp>
+        <p:nvSpPr>
+          <p:cNvPr id="4" name="Slide Number Placeholder 3"/>
+          <p:cNvSpPr>
+            <a:spLocks noGrp="1"/>
+          </p:cNvSpPr>
+          <p:nvPr>
+            <p:ph type="sldNum" sz="quarter" idx="10"/>
+          </p:nvPr>
+        </p:nvSpPr>
+        <p:spPr/>
+        <p:txBody>
+          <a:bodyPr/>
+          <a:lstStyle/>
+          <a:p>
+            <a:fld id="{F7021451-1387-4CA6-816F-3879F97B5CBC}" type="slidenum">
+              <a:rPr lang="en-US"/>
+              <a:t>19</a:t>
             </a:fld>
             <a:endParaRPr lang="en-US"/>
           </a:p>
@@ -2440,7 +2707,7 @@
                 <a:ea typeface="Calibri" pitchFamily="34" charset="-122"/>
                 <a:cs typeface="Calibri" pitchFamily="34" charset="-120"/>
               </a:rPr>
-              <a:t>Mas está concentrada em poucos estados</a:t>
+              <a:t>A receita é bem distribuída entre categorias</a:t>
             </a:r>
             <a:endParaRPr lang="en-US" sz="2800" dirty="0"/>
           </a:p>
@@ -2448,7 +2715,7 @@
       </p:sp>
       <p:pic>
         <p:nvPicPr>
-          <p:cNvPr id="3" name="Image 0" descr="/sessions/nice-great-mayer/mnt/outputs/pptx_project/assets_simples/chart_04_top_estados.png">    </p:cNvPr>
+          <p:cNvPr id="3" name="Image 0" descr="/sessions/nice-great-mayer/mnt/outputs/pptx_project/assets_simples/chart_03_top_categorias.png">    </p:cNvPr>
           <p:cNvPicPr>
             <a:picLocks noChangeAspect="1"/>
           </p:cNvPicPr>
@@ -2506,7 +2773,7 @@
                 <a:ea typeface="Calibri" pitchFamily="34" charset="-122"/>
                 <a:cs typeface="Calibri" pitchFamily="34" charset="-120"/>
               </a:rPr>
-              <a:t>São Paulo sozinho responde por 37% da receita.</a:t>
+              <a:t>São 72 categorias de produto no total.</a:t>
             </a:r>
             <a:endParaRPr lang="en-US" sz="1500" dirty="0"/>
           </a:p>
@@ -2527,7 +2794,7 @@
                 <a:ea typeface="Calibri" pitchFamily="34" charset="-122"/>
                 <a:cs typeface="Calibri" pitchFamily="34" charset="-120"/>
               </a:rPr>
-              <a:t>Os cinco maiores estados somam 73%, e os outros 22 dividem apenas 27%.</a:t>
+              <a:t>As 5 maiores somam 39% da receita, e as outras 67 dividem o restante.</a:t>
             </a:r>
             <a:endParaRPr lang="en-US" sz="1500" dirty="0"/>
           </a:p>
@@ -2548,7 +2815,7 @@
                 <a:ea typeface="Calibri" pitchFamily="34" charset="-122"/>
                 <a:cs typeface="Calibri" pitchFamily="34" charset="-120"/>
               </a:rPr>
-              <a:t>Para mim esse é o maior risco, e ao mesmo tempo onde está o espaço para crescer.</a:t>
+              <a:t>Isso é positivo, porque a empresa não depende de um único tipo de produto.</a:t>
             </a:r>
             <a:endParaRPr lang="en-US" sz="1500" dirty="0"/>
           </a:p>
@@ -2587,7 +2854,7 @@
                 <a:ea typeface="Calibri" pitchFamily="34" charset="-122"/>
                 <a:cs typeface="Calibri" pitchFamily="34" charset="-120"/>
               </a:rPr>
-              <a:t>Fonte: base pública Olist, receita por estado do cliente.</a:t>
+              <a:t>Fonte: base pública Olist, receita por categoria.</a:t>
             </a:r>
             <a:endParaRPr lang="en-US" sz="1100" dirty="0"/>
           </a:p>
@@ -2651,7 +2918,7 @@
                 <a:ea typeface="Calibri" pitchFamily="34" charset="-122"/>
                 <a:cs typeface="Calibri" pitchFamily="34" charset="-120"/>
               </a:rPr>
-              <a:t>A base de vendedores é bem distribuída</a:t>
+              <a:t>Mas está concentrada em poucos estados</a:t>
             </a:r>
             <a:endParaRPr lang="en-US" sz="2800" dirty="0"/>
           </a:p>
@@ -2659,7 +2926,7 @@
       </p:sp>
       <p:pic>
         <p:nvPicPr>
-          <p:cNvPr id="3" name="Image 0" descr="/sessions/nice-great-mayer/mnt/outputs/pptx_project/assets_simples/chart_06_top_sellers.png">    </p:cNvPr>
+          <p:cNvPr id="3" name="Image 0" descr="/sessions/nice-great-mayer/mnt/outputs/pptx_project/assets_simples/chart_04_top_estados.png">    </p:cNvPr>
           <p:cNvPicPr>
             <a:picLocks noChangeAspect="1"/>
           </p:cNvPicPr>
@@ -2717,7 +2984,7 @@
                 <a:ea typeface="Calibri" pitchFamily="34" charset="-122"/>
                 <a:cs typeface="Calibri" pitchFamily="34" charset="-120"/>
               </a:rPr>
-              <a:t>São 3.029 vendedores que venderam no período.</a:t>
+              <a:t>São Paulo sozinho responde por 37% da receita.</a:t>
             </a:r>
             <a:endParaRPr lang="en-US" sz="1500" dirty="0"/>
           </a:p>
@@ -2738,7 +3005,7 @@
                 <a:ea typeface="Calibri" pitchFamily="34" charset="-122"/>
                 <a:cs typeface="Calibri" pitchFamily="34" charset="-120"/>
               </a:rPr>
-              <a:t>Os 10 maiores somam só 13% da receita.</a:t>
+              <a:t>Os cinco maiores estados somam 73%, e os outros 22 dividem apenas 27%.</a:t>
             </a:r>
             <a:endParaRPr lang="en-US" sz="1500" dirty="0"/>
           </a:p>
@@ -2759,7 +3026,7 @@
                 <a:ea typeface="Calibri" pitchFamily="34" charset="-122"/>
                 <a:cs typeface="Calibri" pitchFamily="34" charset="-120"/>
               </a:rPr>
-              <a:t>A empresa não depende de poucos fornecedores, o que reduz o risco.</a:t>
+              <a:t>Para mim esse é o maior risco, e ao mesmo tempo onde está o espaço para crescer.</a:t>
             </a:r>
             <a:endParaRPr lang="en-US" sz="1500" dirty="0"/>
           </a:p>
@@ -2798,7 +3065,7 @@
                 <a:ea typeface="Calibri" pitchFamily="34" charset="-122"/>
                 <a:cs typeface="Calibri" pitchFamily="34" charset="-120"/>
               </a:rPr>
-              <a:t>Fonte: base pública Olist, receita por vendedor.</a:t>
+              <a:t>Fonte: base pública Olist, receita por estado do cliente.</a:t>
             </a:r>
             <a:endParaRPr lang="en-US" sz="1100" dirty="0"/>
           </a:p>
@@ -2862,7 +3129,7 @@
                 <a:ea typeface="Calibri" pitchFamily="34" charset="-122"/>
                 <a:cs typeface="Calibri" pitchFamily="34" charset="-120"/>
               </a:rPr>
-              <a:t>Por que a receita parou de crescer</a:t>
+              <a:t>A base de vendedores é bem distribuída</a:t>
             </a:r>
             <a:endParaRPr lang="en-US" sz="2800" dirty="0"/>
           </a:p>
@@ -2870,7 +3137,7 @@
       </p:sp>
       <p:pic>
         <p:nvPicPr>
-          <p:cNvPr id="3" name="Image 0" descr="/sessions/nice-great-mayer/mnt/outputs/pptx_project/assets_simples/chart_09_vendedores_clientes.png">    </p:cNvPr>
+          <p:cNvPr id="3" name="Image 0" descr="/sessions/nice-great-mayer/mnt/outputs/pptx_project/assets_simples/chart_06_top_sellers.png">    </p:cNvPr>
           <p:cNvPicPr>
             <a:picLocks noChangeAspect="1"/>
           </p:cNvPicPr>
@@ -2928,7 +3195,7 @@
                 <a:ea typeface="Calibri" pitchFamily="34" charset="-122"/>
                 <a:cs typeface="Calibri" pitchFamily="34" charset="-120"/>
               </a:rPr>
-              <a:t>Em 2018 os vendedores ativos subiram de 968 para 1.266, um crescimento de 31%.</a:t>
+              <a:t>São 3.029 vendedores que venderam no período.</a:t>
             </a:r>
             <a:endParaRPr lang="en-US" sz="1500" dirty="0"/>
           </a:p>
@@ -2949,7 +3216,7 @@
                 <a:ea typeface="Calibri" pitchFamily="34" charset="-122"/>
                 <a:cs typeface="Calibri" pitchFamily="34" charset="-120"/>
               </a:rPr>
-              <a:t>Os clientes fizeram o contrário: caíram de 7.088 para 6.380, uma queda de 10%.</a:t>
+              <a:t>Os 10 maiores somam só 13% da receita.</a:t>
             </a:r>
             <a:endParaRPr lang="en-US" sz="1500" dirty="0"/>
           </a:p>
@@ -2970,28 +3237,7 @@
                 <a:ea typeface="Calibri" pitchFamily="34" charset="-122"/>
                 <a:cs typeface="Calibri" pitchFamily="34" charset="-120"/>
               </a:rPr>
-              <a:t>Com isso a receita por vendedor caiu 31%, de R$ 1.138 para R$ 788.</a:t>
-            </a:r>
-            <a:endParaRPr lang="en-US" sz="1500" dirty="0"/>
-          </a:p>
-          <a:p>
-            <a:pPr marL="342900" indent="-342900">
-              <a:lnSpc>
-                <a:spcPct val="130000"/>
-              </a:lnSpc>
-              <a:buSzPct val="100000"/>
-              <a:buChar char="•"/>
-            </a:pPr>
-            <a:r>
-              <a:rPr lang="en-US" sz="1500" dirty="0">
-                <a:solidFill>
-                  <a:srgbClr val="404040"/>
-                </a:solidFill>
-                <a:latin typeface="Calibri" pitchFamily="34" charset="0"/>
-                <a:ea typeface="Calibri" pitchFamily="34" charset="-122"/>
-                <a:cs typeface="Calibri" pitchFamily="34" charset="-120"/>
-              </a:rPr>
-              <a:t>O gargalo não é falta de quem venda, é falta de quem compre.</a:t>
+              <a:t>A empresa não depende de poucos fornecedores, o que reduz o risco.</a:t>
             </a:r>
             <a:endParaRPr lang="en-US" sz="1500" dirty="0"/>
           </a:p>
@@ -3030,7 +3276,7 @@
                 <a:ea typeface="Calibri" pitchFamily="34" charset="-122"/>
                 <a:cs typeface="Calibri" pitchFamily="34" charset="-120"/>
               </a:rPr>
-              <a:t>Fonte: base pública Olist, clientes e vendedores distintos por mês.</a:t>
+              <a:t>Fonte: base pública Olist, receita por vendedor.</a:t>
             </a:r>
             <a:endParaRPr lang="en-US" sz="1100" dirty="0"/>
           </a:p>
@@ -3094,7 +3340,7 @@
                 <a:ea typeface="Calibri" pitchFamily="34" charset="-122"/>
                 <a:cs typeface="Calibri" pitchFamily="34" charset="-120"/>
               </a:rPr>
-              <a:t>Projeção para os próximos meses</a:t>
+              <a:t>A entrega ajuda a explicar a concentração</a:t>
             </a:r>
             <a:endParaRPr lang="en-US" sz="2800" dirty="0"/>
           </a:p>
@@ -3102,7 +3348,7 @@
       </p:sp>
       <p:pic>
         <p:nvPicPr>
-          <p:cNvPr id="3" name="Image 0" descr="/sessions/nice-great-mayer/mnt/outputs/pptx_project/assets_simples/chart_08_previsao.png">    </p:cNvPr>
+          <p:cNvPr id="3" name="Image 0" descr="/sessions/nice-great-mayer/mnt/outputs/pptx_project/assets_simples/chart_10_receita_x_entrega.png">    </p:cNvPr>
           <p:cNvPicPr>
             <a:picLocks noChangeAspect="1"/>
           </p:cNvPicPr>
@@ -3160,7 +3406,7 @@
                 <a:ea typeface="Calibri" pitchFamily="34" charset="-122"/>
                 <a:cs typeface="Calibri" pitchFamily="34" charset="-120"/>
               </a:rPr>
-              <a:t>Como a receita está estável, usei a média dos últimos 3 meses para estimar os próximos.</a:t>
+              <a:t>Os 5 estados que fazem 73% da receita recebem em 10,5 dias na média.</a:t>
             </a:r>
             <a:endParaRPr lang="en-US" sz="1500" dirty="0"/>
           </a:p>
@@ -3181,7 +3427,7 @@
                 <a:ea typeface="Calibri" pitchFamily="34" charset="-122"/>
                 <a:cs typeface="Calibri" pitchFamily="34" charset="-120"/>
               </a:rPr>
-              <a:t>Isso dá cerca de R$ 1 milhão por mês, ou R$ 3 milhões no trimestre.</a:t>
+              <a:t>Os outros 22 esperam 17,3 dias e pagam quase o dobro de frete em proporção ao produto.</a:t>
             </a:r>
             <a:endParaRPr lang="en-US" sz="1500" dirty="0"/>
           </a:p>
@@ -3202,7 +3448,7 @@
                 <a:ea typeface="Calibri" pitchFamily="34" charset="-122"/>
                 <a:cs typeface="Calibri" pitchFamily="34" charset="-120"/>
               </a:rPr>
-              <a:t>O número importa menos que o recado: a melhor estimativa possível é repetir os últimos meses.</a:t>
+              <a:t>A correlação entre demorar e vender menos é de -0,60.</a:t>
             </a:r>
             <a:endParaRPr lang="en-US" sz="1500" dirty="0"/>
           </a:p>
@@ -3223,7 +3469,7 @@
                 <a:ea typeface="Calibri" pitchFamily="34" charset="-122"/>
                 <a:cs typeface="Calibri" pitchFamily="34" charset="-120"/>
               </a:rPr>
-              <a:t>Ou seja, a projeção confirma o platô. Serve como referência, não como meta.</a:t>
+              <a:t>É correlação, não prova de causa. Mas a entrega é a parte que a empresa consegue mudar.</a:t>
             </a:r>
             <a:endParaRPr lang="en-US" sz="1500" dirty="0"/>
           </a:p>
@@ -3262,7 +3508,7 @@
                 <a:ea typeface="Calibri" pitchFamily="34" charset="-122"/>
                 <a:cs typeface="Calibri" pitchFamily="34" charset="-120"/>
               </a:rPr>
-              <a:t>Projeção baseada na média dos últimos 3 meses. A base termina em agosto de 2018.</a:t>
+              <a:t>Fonte: base pública Olist, pedidos entregues entre jan/2017 e ago/2018.</a:t>
             </a:r>
             <a:endParaRPr lang="en-US" sz="1100" dirty="0"/>
           </a:p>
@@ -3301,7 +3547,7 @@
         </p:nvSpPr>
         <p:spPr>
           <a:xfrm>
-            <a:off x="731520" y="548640"/>
+            <a:off x="731520" y="457200"/>
             <a:ext cx="10698480" cy="640080"/>
           </a:xfrm>
           <a:prstGeom prst="rect">
@@ -3318,7 +3564,7 @@
               <a:buNone/>
             </a:pPr>
             <a:r>
-              <a:rPr lang="en-US" sz="3000" b="1" dirty="0">
+              <a:rPr lang="en-US" sz="2800" b="1" dirty="0">
                 <a:solidFill>
                   <a:srgbClr val="1F4E79"/>
                 </a:solidFill>
@@ -3326,22 +3572,45 @@
                 <a:ea typeface="Calibri" pitchFamily="34" charset="-122"/>
                 <a:cs typeface="Calibri" pitchFamily="34" charset="-120"/>
               </a:rPr>
-              <a:t>Recomendações</a:t>
-            </a:r>
-            <a:endParaRPr lang="en-US" sz="3000" dirty="0"/>
-          </a:p>
-        </p:txBody>
-      </p:sp>
-      <p:sp>
-        <p:nvSpPr>
-          <p:cNvPr id="3" name="Text 1"/>
+              <a:t>Atrasar não é o mesmo que demorar</a:t>
+            </a:r>
+            <a:endParaRPr lang="en-US" sz="2800" dirty="0"/>
+          </a:p>
+        </p:txBody>
+      </p:sp>
+      <p:pic>
+        <p:nvPicPr>
+          <p:cNvPr id="3" name="Image 0" descr="/sessions/nice-great-mayer/mnt/outputs/pptx_project/assets_simples/chart_11_atraso_estado.png">    </p:cNvPr>
+          <p:cNvPicPr>
+            <a:picLocks noChangeAspect="1"/>
+          </p:cNvPicPr>
+          <p:nvPr/>
+        </p:nvPicPr>
+        <p:blipFill>
+          <a:blip r:embed="rId1"/>
+          <a:srcRect l="0" r="0" t="0" b="0"/>
+          <a:stretch/>
+        </p:blipFill>
+        <p:spPr>
+          <a:xfrm>
+            <a:off x="822960" y="1280160"/>
+            <a:ext cx="6949440" cy="4206240"/>
+          </a:xfrm>
+          <a:prstGeom prst="rect">
+            <a:avLst/>
+          </a:prstGeom>
+        </p:spPr>
+      </p:pic>
+      <p:sp>
+        <p:nvSpPr>
+          <p:cNvPr id="4" name="Text 1"/>
           <p:cNvSpPr/>
           <p:nvPr/>
         </p:nvSpPr>
         <p:spPr>
           <a:xfrm>
-            <a:off x="914400" y="1554480"/>
-            <a:ext cx="10332720" cy="4389120"/>
+            <a:off x="8046720" y="1463040"/>
+            <a:ext cx="3566160" cy="3840480"/>
           </a:xfrm>
           <a:prstGeom prst="rect">
             <a:avLst/>
@@ -3355,13 +3624,13 @@
           <a:p>
             <a:pPr marL="342900" indent="-342900">
               <a:lnSpc>
-                <a:spcPct val="140000"/>
+                <a:spcPct val="130000"/>
               </a:lnSpc>
               <a:buSzPct val="100000"/>
               <a:buChar char="•"/>
             </a:pPr>
             <a:r>
-              <a:rPr lang="en-US" sz="2000" dirty="0">
+              <a:rPr lang="en-US" sz="1500" dirty="0">
                 <a:solidFill>
                   <a:srgbClr val="404040"/>
                 </a:solidFill>
@@ -3369,20 +3638,20 @@
                 <a:ea typeface="Calibri" pitchFamily="34" charset="-122"/>
                 <a:cs typeface="Calibri" pitchFamily="34" charset="-120"/>
               </a:rPr>
-              <a:t>Priorizar atração e retenção de clientes, que foi o lado que parou de crescer e trava a receita</a:t>
-            </a:r>
-            <a:endParaRPr lang="en-US" sz="2000" dirty="0"/>
+              <a:t>Alagoas entrega em 24 dias e atrasa 21,5% das vezes.</a:t>
+            </a:r>
+            <a:endParaRPr lang="en-US" sz="1500" dirty="0"/>
           </a:p>
           <a:p>
             <a:pPr marL="342900" indent="-342900">
               <a:lnSpc>
-                <a:spcPct val="140000"/>
+                <a:spcPct val="130000"/>
               </a:lnSpc>
               <a:buSzPct val="100000"/>
               <a:buChar char="•"/>
             </a:pPr>
             <a:r>
-              <a:rPr lang="en-US" sz="2000" dirty="0">
+              <a:rPr lang="en-US" sz="1500" dirty="0">
                 <a:solidFill>
                   <a:srgbClr val="404040"/>
                 </a:solidFill>
@@ -3390,20 +3659,20 @@
                 <a:ea typeface="Calibri" pitchFamily="34" charset="-122"/>
                 <a:cs typeface="Calibri" pitchFamily="34" charset="-120"/>
               </a:rPr>
-              <a:t>Crescer fora dos cinco maiores estados, que hoje concentram 73% da receita</a:t>
-            </a:r>
-            <a:endParaRPr lang="en-US" sz="2000" dirty="0"/>
+              <a:t>Roraima demora mais, 29,5 dias, e atrasa 12,5%.</a:t>
+            </a:r>
+            <a:endParaRPr lang="en-US" sz="1500" dirty="0"/>
           </a:p>
           <a:p>
             <a:pPr marL="342900" indent="-342900">
               <a:lnSpc>
-                <a:spcPct val="140000"/>
+                <a:spcPct val="130000"/>
               </a:lnSpc>
               <a:buSzPct val="100000"/>
               <a:buChar char="•"/>
             </a:pPr>
             <a:r>
-              <a:rPr lang="en-US" sz="2000" dirty="0">
+              <a:rPr lang="en-US" sz="1500" dirty="0">
                 <a:solidFill>
                   <a:srgbClr val="404040"/>
                 </a:solidFill>
@@ -3411,20 +3680,20 @@
                 <a:ea typeface="Calibri" pitchFamily="34" charset="-122"/>
                 <a:cs typeface="Calibri" pitchFamily="34" charset="-120"/>
               </a:rPr>
-              <a:t>Acompanhar a receita por vendedor, que caiu quase um terço em oito meses</a:t>
-            </a:r>
-            <a:endParaRPr lang="en-US" sz="2000" dirty="0"/>
+              <a:t>Onde o atraso é alto sem ser o mais lento, o problema é o prazo prometido.</a:t>
+            </a:r>
+            <a:endParaRPr lang="en-US" sz="1500" dirty="0"/>
           </a:p>
           <a:p>
             <a:pPr marL="342900" indent="-342900">
               <a:lnSpc>
-                <a:spcPct val="140000"/>
+                <a:spcPct val="130000"/>
               </a:lnSpc>
               <a:buSzPct val="100000"/>
               <a:buChar char="•"/>
             </a:pPr>
             <a:r>
-              <a:rPr lang="en-US" sz="2000" dirty="0">
+              <a:rPr lang="en-US" sz="1500" dirty="0">
                 <a:solidFill>
                   <a:srgbClr val="404040"/>
                 </a:solidFill>
@@ -3432,9 +3701,48 @@
                 <a:ea typeface="Calibri" pitchFamily="34" charset="-122"/>
                 <a:cs typeface="Calibri" pitchFamily="34" charset="-120"/>
               </a:rPr>
-              <a:t>Trabalhar o valor do pedido, já que o crescimento veio de volume e não de ticket maior</a:t>
-            </a:r>
-            <a:endParaRPr lang="en-US" sz="2000" dirty="0"/>
+              <a:t>Corrigir a promessa é mais barato e mais rápido que mudar a operação.</a:t>
+            </a:r>
+            <a:endParaRPr lang="en-US" sz="1500" dirty="0"/>
+          </a:p>
+        </p:txBody>
+      </p:sp>
+      <p:sp>
+        <p:nvSpPr>
+          <p:cNvPr id="5" name="Text 2"/>
+          <p:cNvSpPr/>
+          <p:nvPr/>
+        </p:nvSpPr>
+        <p:spPr>
+          <a:xfrm>
+            <a:off x="731520" y="6035040"/>
+            <a:ext cx="10698480" cy="274320"/>
+          </a:xfrm>
+          <a:prstGeom prst="rect">
+            <a:avLst/>
+          </a:prstGeom>
+          <a:noFill/>
+          <a:ln/>
+        </p:spPr>
+        <p:txBody>
+          <a:bodyPr wrap="square" rtlCol="0" anchor="ctr"/>
+          <a:lstStyle/>
+          <a:p>
+            <a:pPr indent="0" marL="0">
+              <a:buNone/>
+            </a:pPr>
+            <a:r>
+              <a:rPr lang="en-US" sz="1100" i="1" dirty="0">
+                <a:solidFill>
+                  <a:srgbClr val="808080"/>
+                </a:solidFill>
+                <a:latin typeface="Calibri" pitchFamily="34" charset="0"/>
+                <a:ea typeface="Calibri" pitchFamily="34" charset="-122"/>
+                <a:cs typeface="Calibri" pitchFamily="34" charset="-120"/>
+              </a:rPr>
+              <a:t>Fonte: base pública Olist. Atraso comparado apenas pela data, sem a hora.</a:t>
+            </a:r>
+            <a:endParaRPr lang="en-US" sz="1100" dirty="0"/>
           </a:p>
         </p:txBody>
       </p:sp>
@@ -3471,6 +3779,470 @@
         </p:nvSpPr>
         <p:spPr>
           <a:xfrm>
+            <a:off x="731520" y="457200"/>
+            <a:ext cx="10698480" cy="640080"/>
+          </a:xfrm>
+          <a:prstGeom prst="rect">
+            <a:avLst/>
+          </a:prstGeom>
+          <a:noFill/>
+          <a:ln/>
+        </p:spPr>
+        <p:txBody>
+          <a:bodyPr wrap="square" rtlCol="0" anchor="ctr"/>
+          <a:lstStyle/>
+          <a:p>
+            <a:pPr indent="0" marL="0">
+              <a:buNone/>
+            </a:pPr>
+            <a:r>
+              <a:rPr lang="en-US" sz="2800" b="1" dirty="0">
+                <a:solidFill>
+                  <a:srgbClr val="1F4E79"/>
+                </a:solidFill>
+                <a:latin typeface="Calibri" pitchFamily="34" charset="0"/>
+                <a:ea typeface="Calibri" pitchFamily="34" charset="-122"/>
+                <a:cs typeface="Calibri" pitchFamily="34" charset="-120"/>
+              </a:rPr>
+              <a:t>O atraso afasta o cliente, mas menos do que parece</a:t>
+            </a:r>
+            <a:endParaRPr lang="en-US" sz="2800" dirty="0"/>
+          </a:p>
+        </p:txBody>
+      </p:sp>
+      <p:pic>
+        <p:nvPicPr>
+          <p:cNvPr id="3" name="Image 0" descr="/sessions/nice-great-mayer/mnt/outputs/pptx_project/assets_simples/chart_12_recompra_atraso.png">    </p:cNvPr>
+          <p:cNvPicPr>
+            <a:picLocks noChangeAspect="1"/>
+          </p:cNvPicPr>
+          <p:nvPr/>
+        </p:nvPicPr>
+        <p:blipFill>
+          <a:blip r:embed="rId1"/>
+          <a:srcRect l="0" r="0" t="0" b="0"/>
+          <a:stretch/>
+        </p:blipFill>
+        <p:spPr>
+          <a:xfrm>
+            <a:off x="822960" y="1280160"/>
+            <a:ext cx="6949440" cy="4206240"/>
+          </a:xfrm>
+          <a:prstGeom prst="rect">
+            <a:avLst/>
+          </a:prstGeom>
+        </p:spPr>
+      </p:pic>
+      <p:sp>
+        <p:nvSpPr>
+          <p:cNvPr id="4" name="Text 1"/>
+          <p:cNvSpPr/>
+          <p:nvPr/>
+        </p:nvSpPr>
+        <p:spPr>
+          <a:xfrm>
+            <a:off x="8046720" y="1463040"/>
+            <a:ext cx="3566160" cy="3840480"/>
+          </a:xfrm>
+          <a:prstGeom prst="rect">
+            <a:avLst/>
+          </a:prstGeom>
+          <a:noFill/>
+          <a:ln/>
+        </p:spPr>
+        <p:txBody>
+          <a:bodyPr wrap="square" rtlCol="0" anchor="ctr"/>
+          <a:lstStyle/>
+          <a:p>
+            <a:pPr marL="342900" indent="-342900">
+              <a:lnSpc>
+                <a:spcPct val="130000"/>
+              </a:lnSpc>
+              <a:buSzPct val="100000"/>
+              <a:buChar char="•"/>
+            </a:pPr>
+            <a:r>
+              <a:rPr lang="en-US" sz="1500" dirty="0">
+                <a:solidFill>
+                  <a:srgbClr val="404040"/>
+                </a:solidFill>
+                <a:latin typeface="Calibri" pitchFamily="34" charset="0"/>
+                <a:ea typeface="Calibri" pitchFamily="34" charset="-122"/>
+                <a:cs typeface="Calibri" pitchFamily="34" charset="-120"/>
+              </a:rPr>
+              <a:t>Primeira compra no prazo: 4,08% voltaram a comprar. Com atraso: 3,16%.</a:t>
+            </a:r>
+            <a:endParaRPr lang="en-US" sz="1500" dirty="0"/>
+          </a:p>
+          <a:p>
+            <a:pPr marL="342900" indent="-342900">
+              <a:lnSpc>
+                <a:spcPct val="130000"/>
+              </a:lnSpc>
+              <a:buSzPct val="100000"/>
+              <a:buChar char="•"/>
+            </a:pPr>
+            <a:r>
+              <a:rPr lang="en-US" sz="1500" dirty="0">
+                <a:solidFill>
+                  <a:srgbClr val="404040"/>
+                </a:solidFill>
+                <a:latin typeface="Calibri" pitchFamily="34" charset="0"/>
+                <a:ea typeface="Calibri" pitchFamily="34" charset="-122"/>
+                <a:cs typeface="Calibri" pitchFamily="34" charset="-120"/>
+              </a:rPr>
+              <a:t>Queda de 22,6%, e o teste confirma que não é acaso (p = 0,007).</a:t>
+            </a:r>
+            <a:endParaRPr lang="en-US" sz="1500" dirty="0"/>
+          </a:p>
+          <a:p>
+            <a:pPr marL="342900" indent="-342900">
+              <a:lnSpc>
+                <a:spcPct val="130000"/>
+              </a:lnSpc>
+              <a:buSzPct val="100000"/>
+              <a:buChar char="•"/>
+            </a:pPr>
+            <a:r>
+              <a:rPr lang="en-US" sz="1500" dirty="0">
+                <a:solidFill>
+                  <a:srgbClr val="404040"/>
+                </a:solidFill>
+                <a:latin typeface="Calibri" pitchFamily="34" charset="0"/>
+                <a:ea typeface="Calibri" pitchFamily="34" charset="-122"/>
+                <a:cs typeface="Calibri" pitchFamily="34" charset="-120"/>
+              </a:rPr>
+              <a:t>Mas a diferença absoluta é de 0,92 ponto percentual.</a:t>
+            </a:r>
+            <a:endParaRPr lang="en-US" sz="1500" dirty="0"/>
+          </a:p>
+          <a:p>
+            <a:pPr marL="342900" indent="-342900">
+              <a:lnSpc>
+                <a:spcPct val="130000"/>
+              </a:lnSpc>
+              <a:buSzPct val="100000"/>
+              <a:buChar char="•"/>
+            </a:pPr>
+            <a:r>
+              <a:rPr lang="en-US" sz="1500" dirty="0">
+                <a:solidFill>
+                  <a:srgbClr val="404040"/>
+                </a:solidFill>
+                <a:latin typeface="Calibri" pitchFamily="34" charset="0"/>
+                <a:ea typeface="Calibri" pitchFamily="34" charset="-122"/>
+                <a:cs typeface="Calibri" pitchFamily="34" charset="-120"/>
+              </a:rPr>
+              <a:t>Mesmo entregando no prazo, cerca de 96% não voltam. O problema de retenção é maior que a entrega.</a:t>
+            </a:r>
+            <a:endParaRPr lang="en-US" sz="1500" dirty="0"/>
+          </a:p>
+        </p:txBody>
+      </p:sp>
+      <p:sp>
+        <p:nvSpPr>
+          <p:cNvPr id="5" name="Text 2"/>
+          <p:cNvSpPr/>
+          <p:nvPr/>
+        </p:nvSpPr>
+        <p:spPr>
+          <a:xfrm>
+            <a:off x="731520" y="6035040"/>
+            <a:ext cx="10698480" cy="274320"/>
+          </a:xfrm>
+          <a:prstGeom prst="rect">
+            <a:avLst/>
+          </a:prstGeom>
+          <a:noFill/>
+          <a:ln/>
+        </p:spPr>
+        <p:txBody>
+          <a:bodyPr wrap="square" rtlCol="0" anchor="ctr"/>
+          <a:lstStyle/>
+          <a:p>
+            <a:pPr indent="0" marL="0">
+              <a:buNone/>
+            </a:pPr>
+            <a:r>
+              <a:rPr lang="en-US" sz="1100" i="1" dirty="0">
+                <a:solidFill>
+                  <a:srgbClr val="808080"/>
+                </a:solidFill>
+                <a:latin typeface="Calibri" pitchFamily="34" charset="0"/>
+                <a:ea typeface="Calibri" pitchFamily="34" charset="-122"/>
+                <a:cs typeface="Calibri" pitchFamily="34" charset="-120"/>
+              </a:rPr>
+              <a:t>Considera apenas clientes com primeira compra até fev/2018, para dar 6 meses de janela.</a:t>
+            </a:r>
+            <a:endParaRPr lang="en-US" sz="1100" dirty="0"/>
+          </a:p>
+        </p:txBody>
+      </p:sp>
+    </p:spTree>
+  </p:cSld>
+  <p:clrMapOvr>
+    <a:masterClrMapping/>
+  </p:clrMapOvr>
+</p:sld>
+</file>
+
+<file path=ppt/slides/slide16.xml><?xml version="1.0" encoding="utf-8"?>
+<p:sld xmlns:a="http://schemas.openxmlformats.org/drawingml/2006/main" xmlns:r="http://schemas.openxmlformats.org/officeDocument/2006/relationships" xmlns:p="http://schemas.openxmlformats.org/presentationml/2006/main">
+  <p:cSld name="Slide 16">
+    <p:spTree>
+      <p:nvGrpSpPr>
+        <p:cNvPr id="1" name=""/>
+        <p:cNvGrpSpPr/>
+        <p:nvPr/>
+      </p:nvGrpSpPr>
+      <p:grpSpPr>
+        <a:xfrm>
+          <a:off x="0" y="0"/>
+          <a:ext cx="0" cy="0"/>
+          <a:chOff x="0" y="0"/>
+          <a:chExt cx="0" cy="0"/>
+        </a:xfrm>
+      </p:grpSpPr>
+      <p:sp>
+        <p:nvSpPr>
+          <p:cNvPr id="2" name="Text 0"/>
+          <p:cNvSpPr/>
+          <p:nvPr/>
+        </p:nvSpPr>
+        <p:spPr>
+          <a:xfrm>
+            <a:off x="731520" y="457200"/>
+            <a:ext cx="10698480" cy="640080"/>
+          </a:xfrm>
+          <a:prstGeom prst="rect">
+            <a:avLst/>
+          </a:prstGeom>
+          <a:noFill/>
+          <a:ln/>
+        </p:spPr>
+        <p:txBody>
+          <a:bodyPr wrap="square" rtlCol="0" anchor="ctr"/>
+          <a:lstStyle/>
+          <a:p>
+            <a:pPr indent="0" marL="0">
+              <a:buNone/>
+            </a:pPr>
+            <a:r>
+              <a:rPr lang="en-US" sz="2800" b="1" dirty="0">
+                <a:solidFill>
+                  <a:srgbClr val="1F4E79"/>
+                </a:solidFill>
+                <a:latin typeface="Calibri" pitchFamily="34" charset="0"/>
+                <a:ea typeface="Calibri" pitchFamily="34" charset="-122"/>
+                <a:cs typeface="Calibri" pitchFamily="34" charset="-120"/>
+              </a:rPr>
+              <a:t>Projeção para os próximos meses</a:t>
+            </a:r>
+            <a:endParaRPr lang="en-US" sz="2800" dirty="0"/>
+          </a:p>
+        </p:txBody>
+      </p:sp>
+      <p:pic>
+        <p:nvPicPr>
+          <p:cNvPr id="3" name="Image 0" descr="/sessions/nice-great-mayer/mnt/outputs/pptx_project/assets_simples/chart_08_previsao.png">    </p:cNvPr>
+          <p:cNvPicPr>
+            <a:picLocks noChangeAspect="1"/>
+          </p:cNvPicPr>
+          <p:nvPr/>
+        </p:nvPicPr>
+        <p:blipFill>
+          <a:blip r:embed="rId1"/>
+          <a:srcRect l="0" r="0" t="0" b="0"/>
+          <a:stretch/>
+        </p:blipFill>
+        <p:spPr>
+          <a:xfrm>
+            <a:off x="822960" y="1280160"/>
+            <a:ext cx="6949440" cy="4206240"/>
+          </a:xfrm>
+          <a:prstGeom prst="rect">
+            <a:avLst/>
+          </a:prstGeom>
+        </p:spPr>
+      </p:pic>
+      <p:sp>
+        <p:nvSpPr>
+          <p:cNvPr id="4" name="Text 1"/>
+          <p:cNvSpPr/>
+          <p:nvPr/>
+        </p:nvSpPr>
+        <p:spPr>
+          <a:xfrm>
+            <a:off x="8046720" y="1463040"/>
+            <a:ext cx="3566160" cy="3840480"/>
+          </a:xfrm>
+          <a:prstGeom prst="rect">
+            <a:avLst/>
+          </a:prstGeom>
+          <a:noFill/>
+          <a:ln/>
+        </p:spPr>
+        <p:txBody>
+          <a:bodyPr wrap="square" rtlCol="0" anchor="ctr"/>
+          <a:lstStyle/>
+          <a:p>
+            <a:pPr marL="342900" indent="-342900">
+              <a:lnSpc>
+                <a:spcPct val="130000"/>
+              </a:lnSpc>
+              <a:buSzPct val="100000"/>
+              <a:buChar char="•"/>
+            </a:pPr>
+            <a:r>
+              <a:rPr lang="en-US" sz="1500" dirty="0">
+                <a:solidFill>
+                  <a:srgbClr val="404040"/>
+                </a:solidFill>
+                <a:latin typeface="Calibri" pitchFamily="34" charset="0"/>
+                <a:ea typeface="Calibri" pitchFamily="34" charset="-122"/>
+                <a:cs typeface="Calibri" pitchFamily="34" charset="-120"/>
+              </a:rPr>
+              <a:t>Como a receita está estável, usei a média dos últimos 3 meses para estimar os próximos.</a:t>
+            </a:r>
+            <a:endParaRPr lang="en-US" sz="1500" dirty="0"/>
+          </a:p>
+          <a:p>
+            <a:pPr marL="342900" indent="-342900">
+              <a:lnSpc>
+                <a:spcPct val="130000"/>
+              </a:lnSpc>
+              <a:buSzPct val="100000"/>
+              <a:buChar char="•"/>
+            </a:pPr>
+            <a:r>
+              <a:rPr lang="en-US" sz="1500" dirty="0">
+                <a:solidFill>
+                  <a:srgbClr val="404040"/>
+                </a:solidFill>
+                <a:latin typeface="Calibri" pitchFamily="34" charset="0"/>
+                <a:ea typeface="Calibri" pitchFamily="34" charset="-122"/>
+                <a:cs typeface="Calibri" pitchFamily="34" charset="-120"/>
+              </a:rPr>
+              <a:t>Isso dá cerca de R$ 1 milhão por mês, ou R$ 3 milhões no trimestre.</a:t>
+            </a:r>
+            <a:endParaRPr lang="en-US" sz="1500" dirty="0"/>
+          </a:p>
+          <a:p>
+            <a:pPr marL="342900" indent="-342900">
+              <a:lnSpc>
+                <a:spcPct val="130000"/>
+              </a:lnSpc>
+              <a:buSzPct val="100000"/>
+              <a:buChar char="•"/>
+            </a:pPr>
+            <a:r>
+              <a:rPr lang="en-US" sz="1500" dirty="0">
+                <a:solidFill>
+                  <a:srgbClr val="404040"/>
+                </a:solidFill>
+                <a:latin typeface="Calibri" pitchFamily="34" charset="0"/>
+                <a:ea typeface="Calibri" pitchFamily="34" charset="-122"/>
+                <a:cs typeface="Calibri" pitchFamily="34" charset="-120"/>
+              </a:rPr>
+              <a:t>O número importa menos que o recado: a melhor estimativa possível é repetir os últimos meses.</a:t>
+            </a:r>
+            <a:endParaRPr lang="en-US" sz="1500" dirty="0"/>
+          </a:p>
+          <a:p>
+            <a:pPr marL="342900" indent="-342900">
+              <a:lnSpc>
+                <a:spcPct val="130000"/>
+              </a:lnSpc>
+              <a:buSzPct val="100000"/>
+              <a:buChar char="•"/>
+            </a:pPr>
+            <a:r>
+              <a:rPr lang="en-US" sz="1500" dirty="0">
+                <a:solidFill>
+                  <a:srgbClr val="404040"/>
+                </a:solidFill>
+                <a:latin typeface="Calibri" pitchFamily="34" charset="0"/>
+                <a:ea typeface="Calibri" pitchFamily="34" charset="-122"/>
+                <a:cs typeface="Calibri" pitchFamily="34" charset="-120"/>
+              </a:rPr>
+              <a:t>Ou seja, a projeção confirma o platô. Serve como referência, não como meta.</a:t>
+            </a:r>
+            <a:endParaRPr lang="en-US" sz="1500" dirty="0"/>
+          </a:p>
+        </p:txBody>
+      </p:sp>
+      <p:sp>
+        <p:nvSpPr>
+          <p:cNvPr id="5" name="Text 2"/>
+          <p:cNvSpPr/>
+          <p:nvPr/>
+        </p:nvSpPr>
+        <p:spPr>
+          <a:xfrm>
+            <a:off x="731520" y="6035040"/>
+            <a:ext cx="10698480" cy="274320"/>
+          </a:xfrm>
+          <a:prstGeom prst="rect">
+            <a:avLst/>
+          </a:prstGeom>
+          <a:noFill/>
+          <a:ln/>
+        </p:spPr>
+        <p:txBody>
+          <a:bodyPr wrap="square" rtlCol="0" anchor="ctr"/>
+          <a:lstStyle/>
+          <a:p>
+            <a:pPr indent="0" marL="0">
+              <a:buNone/>
+            </a:pPr>
+            <a:r>
+              <a:rPr lang="en-US" sz="1100" i="1" dirty="0">
+                <a:solidFill>
+                  <a:srgbClr val="808080"/>
+                </a:solidFill>
+                <a:latin typeface="Calibri" pitchFamily="34" charset="0"/>
+                <a:ea typeface="Calibri" pitchFamily="34" charset="-122"/>
+                <a:cs typeface="Calibri" pitchFamily="34" charset="-120"/>
+              </a:rPr>
+              <a:t>Projeção baseada na média dos últimos 3 meses. A base termina em agosto de 2018.</a:t>
+            </a:r>
+            <a:endParaRPr lang="en-US" sz="1100" dirty="0"/>
+          </a:p>
+        </p:txBody>
+      </p:sp>
+    </p:spTree>
+  </p:cSld>
+  <p:clrMapOvr>
+    <a:masterClrMapping/>
+  </p:clrMapOvr>
+</p:sld>
+</file>
+
+<file path=ppt/slides/slide17.xml><?xml version="1.0" encoding="utf-8"?>
+<p:sld xmlns:a="http://schemas.openxmlformats.org/drawingml/2006/main" xmlns:r="http://schemas.openxmlformats.org/officeDocument/2006/relationships" xmlns:p="http://schemas.openxmlformats.org/presentationml/2006/main">
+  <p:cSld name="Slide 17">
+    <p:spTree>
+      <p:nvGrpSpPr>
+        <p:cNvPr id="1" name=""/>
+        <p:cNvGrpSpPr/>
+        <p:nvPr/>
+      </p:nvGrpSpPr>
+      <p:grpSpPr>
+        <a:xfrm>
+          <a:off x="0" y="0"/>
+          <a:ext cx="0" cy="0"/>
+          <a:chOff x="0" y="0"/>
+          <a:chExt cx="0" cy="0"/>
+        </a:xfrm>
+      </p:grpSpPr>
+      <p:sp>
+        <p:nvSpPr>
+          <p:cNvPr id="2" name="Text 0"/>
+          <p:cNvSpPr/>
+          <p:nvPr/>
+        </p:nvSpPr>
+        <p:spPr>
+          <a:xfrm>
             <a:off x="731520" y="548640"/>
             <a:ext cx="10698480" cy="640080"/>
           </a:xfrm>
@@ -3496,7 +4268,7 @@
                 <a:ea typeface="Calibri" pitchFamily="34" charset="-122"/>
                 <a:cs typeface="Calibri" pitchFamily="34" charset="-120"/>
               </a:rPr>
-              <a:t>Uma limitação importante</a:t>
+              <a:t>Recomendações</a:t>
             </a:r>
             <a:endParaRPr lang="en-US" sz="3000" dirty="0"/>
           </a:p>
@@ -3539,7 +4311,7 @@
                 <a:ea typeface="Calibri" pitchFamily="34" charset="-122"/>
                 <a:cs typeface="Calibri" pitchFamily="34" charset="-120"/>
               </a:rPr>
-              <a:t>A base não informa quanto a Olist recebe de comissão em cada venda</a:t>
+              <a:t>Priorizar atração e retenção de clientes, que foi o lado que parou de crescer e trava a receita</a:t>
             </a:r>
             <a:endParaRPr lang="en-US" sz="2000" dirty="0"/>
           </a:p>
@@ -3560,7 +4332,7 @@
                 <a:ea typeface="Calibri" pitchFamily="34" charset="-122"/>
                 <a:cs typeface="Calibri" pitchFamily="34" charset="-120"/>
               </a:rPr>
-              <a:t>Por isso, a receita analisada aqui é o valor total da venda, e não o que entra no caixa da empresa</a:t>
+              <a:t>Tratar a expansão fora do Sudeste como problema de logística, não só de ação comercial</a:t>
             </a:r>
             <a:endParaRPr lang="en-US" sz="2000" dirty="0"/>
           </a:p>
@@ -3581,7 +4353,7 @@
                 <a:ea typeface="Calibri" pitchFamily="34" charset="-122"/>
                 <a:cs typeface="Calibri" pitchFamily="34" charset="-120"/>
               </a:rPr>
-              <a:t>Isso significa que não é possível calcular lucro ou margem com esses dados</a:t>
+              <a:t>Revisar o prazo prometido onde ele está mal calibrado, como em Alagoas</a:t>
             </a:r>
             <a:endParaRPr lang="en-US" sz="2000" dirty="0"/>
           </a:p>
@@ -3602,7 +4374,28 @@
                 <a:ea typeface="Calibri" pitchFamily="34" charset="-122"/>
                 <a:cs typeface="Calibri" pitchFamily="34" charset="-120"/>
               </a:rPr>
-              <a:t>As conclusões se limitam a volume de vendas, receita e concentração</a:t>
+              <a:t>Acompanhar a receita por vendedor, que caiu quase um terço em oito meses</a:t>
+            </a:r>
+            <a:endParaRPr lang="en-US" sz="2000" dirty="0"/>
+          </a:p>
+          <a:p>
+            <a:pPr marL="342900" indent="-342900">
+              <a:lnSpc>
+                <a:spcPct val="140000"/>
+              </a:lnSpc>
+              <a:buSzPct val="100000"/>
+              <a:buChar char="•"/>
+            </a:pPr>
+            <a:r>
+              <a:rPr lang="en-US" sz="2000" dirty="0">
+                <a:solidFill>
+                  <a:srgbClr val="404040"/>
+                </a:solidFill>
+                <a:latin typeface="Calibri" pitchFamily="34" charset="0"/>
+                <a:ea typeface="Calibri" pitchFamily="34" charset="-122"/>
+                <a:cs typeface="Calibri" pitchFamily="34" charset="-120"/>
+              </a:rPr>
+              <a:t>Trabalhar o valor do pedido, já que o crescimento veio de volume e não de ticket maior</a:t>
             </a:r>
             <a:endParaRPr lang="en-US" sz="2000" dirty="0"/>
           </a:p>
@@ -3616,9 +4409,179 @@
 </p:sld>
 </file>
 
-<file path=ppt/slides/slide16.xml><?xml version="1.0" encoding="utf-8"?>
+<file path=ppt/slides/slide18.xml><?xml version="1.0" encoding="utf-8"?>
 <p:sld xmlns:a="http://schemas.openxmlformats.org/drawingml/2006/main" xmlns:r="http://schemas.openxmlformats.org/officeDocument/2006/relationships" xmlns:p="http://schemas.openxmlformats.org/presentationml/2006/main">
-  <p:cSld name="Slide 16">
+  <p:cSld name="Slide 18">
+    <p:spTree>
+      <p:nvGrpSpPr>
+        <p:cNvPr id="1" name=""/>
+        <p:cNvGrpSpPr/>
+        <p:nvPr/>
+      </p:nvGrpSpPr>
+      <p:grpSpPr>
+        <a:xfrm>
+          <a:off x="0" y="0"/>
+          <a:ext cx="0" cy="0"/>
+          <a:chOff x="0" y="0"/>
+          <a:chExt cx="0" cy="0"/>
+        </a:xfrm>
+      </p:grpSpPr>
+      <p:sp>
+        <p:nvSpPr>
+          <p:cNvPr id="2" name="Text 0"/>
+          <p:cNvSpPr/>
+          <p:nvPr/>
+        </p:nvSpPr>
+        <p:spPr>
+          <a:xfrm>
+            <a:off x="731520" y="548640"/>
+            <a:ext cx="10698480" cy="640080"/>
+          </a:xfrm>
+          <a:prstGeom prst="rect">
+            <a:avLst/>
+          </a:prstGeom>
+          <a:noFill/>
+          <a:ln/>
+        </p:spPr>
+        <p:txBody>
+          <a:bodyPr wrap="square" rtlCol="0" anchor="ctr"/>
+          <a:lstStyle/>
+          <a:p>
+            <a:pPr indent="0" marL="0">
+              <a:buNone/>
+            </a:pPr>
+            <a:r>
+              <a:rPr lang="en-US" sz="3000" b="1" dirty="0">
+                <a:solidFill>
+                  <a:srgbClr val="1F4E79"/>
+                </a:solidFill>
+                <a:latin typeface="Calibri" pitchFamily="34" charset="0"/>
+                <a:ea typeface="Calibri" pitchFamily="34" charset="-122"/>
+                <a:cs typeface="Calibri" pitchFamily="34" charset="-120"/>
+              </a:rPr>
+              <a:t>Uma limitação importante</a:t>
+            </a:r>
+            <a:endParaRPr lang="en-US" sz="3000" dirty="0"/>
+          </a:p>
+        </p:txBody>
+      </p:sp>
+      <p:sp>
+        <p:nvSpPr>
+          <p:cNvPr id="3" name="Text 1"/>
+          <p:cNvSpPr/>
+          <p:nvPr/>
+        </p:nvSpPr>
+        <p:spPr>
+          <a:xfrm>
+            <a:off x="914400" y="1554480"/>
+            <a:ext cx="10332720" cy="4389120"/>
+          </a:xfrm>
+          <a:prstGeom prst="rect">
+            <a:avLst/>
+          </a:prstGeom>
+          <a:noFill/>
+          <a:ln/>
+        </p:spPr>
+        <p:txBody>
+          <a:bodyPr wrap="square" rtlCol="0" anchor="ctr"/>
+          <a:lstStyle/>
+          <a:p>
+            <a:pPr marL="342900" indent="-342900">
+              <a:lnSpc>
+                <a:spcPct val="140000"/>
+              </a:lnSpc>
+              <a:buSzPct val="100000"/>
+              <a:buChar char="•"/>
+            </a:pPr>
+            <a:r>
+              <a:rPr lang="en-US" sz="2000" dirty="0">
+                <a:solidFill>
+                  <a:srgbClr val="404040"/>
+                </a:solidFill>
+                <a:latin typeface="Calibri" pitchFamily="34" charset="0"/>
+                <a:ea typeface="Calibri" pitchFamily="34" charset="-122"/>
+                <a:cs typeface="Calibri" pitchFamily="34" charset="-120"/>
+              </a:rPr>
+              <a:t>A base não informa quanto a Olist recebe de comissão em cada venda</a:t>
+            </a:r>
+            <a:endParaRPr lang="en-US" sz="2000" dirty="0"/>
+          </a:p>
+          <a:p>
+            <a:pPr marL="342900" indent="-342900">
+              <a:lnSpc>
+                <a:spcPct val="140000"/>
+              </a:lnSpc>
+              <a:buSzPct val="100000"/>
+              <a:buChar char="•"/>
+            </a:pPr>
+            <a:r>
+              <a:rPr lang="en-US" sz="2000" dirty="0">
+                <a:solidFill>
+                  <a:srgbClr val="404040"/>
+                </a:solidFill>
+                <a:latin typeface="Calibri" pitchFamily="34" charset="0"/>
+                <a:ea typeface="Calibri" pitchFamily="34" charset="-122"/>
+                <a:cs typeface="Calibri" pitchFamily="34" charset="-120"/>
+              </a:rPr>
+              <a:t>Por isso, a receita analisada aqui é o valor total da venda, e não o que entra no caixa da empresa</a:t>
+            </a:r>
+            <a:endParaRPr lang="en-US" sz="2000" dirty="0"/>
+          </a:p>
+          <a:p>
+            <a:pPr marL="342900" indent="-342900">
+              <a:lnSpc>
+                <a:spcPct val="140000"/>
+              </a:lnSpc>
+              <a:buSzPct val="100000"/>
+              <a:buChar char="•"/>
+            </a:pPr>
+            <a:r>
+              <a:rPr lang="en-US" sz="2000" dirty="0">
+                <a:solidFill>
+                  <a:srgbClr val="404040"/>
+                </a:solidFill>
+                <a:latin typeface="Calibri" pitchFamily="34" charset="0"/>
+                <a:ea typeface="Calibri" pitchFamily="34" charset="-122"/>
+                <a:cs typeface="Calibri" pitchFamily="34" charset="-120"/>
+              </a:rPr>
+              <a:t>Isso significa que não é possível calcular lucro ou margem com esses dados</a:t>
+            </a:r>
+            <a:endParaRPr lang="en-US" sz="2000" dirty="0"/>
+          </a:p>
+          <a:p>
+            <a:pPr marL="342900" indent="-342900">
+              <a:lnSpc>
+                <a:spcPct val="140000"/>
+              </a:lnSpc>
+              <a:buSzPct val="100000"/>
+              <a:buChar char="•"/>
+            </a:pPr>
+            <a:r>
+              <a:rPr lang="en-US" sz="2000" dirty="0">
+                <a:solidFill>
+                  <a:srgbClr val="404040"/>
+                </a:solidFill>
+                <a:latin typeface="Calibri" pitchFamily="34" charset="0"/>
+                <a:ea typeface="Calibri" pitchFamily="34" charset="-122"/>
+                <a:cs typeface="Calibri" pitchFamily="34" charset="-120"/>
+              </a:rPr>
+              <a:t>As conclusões se limitam a volume de vendas, receita e concentração</a:t>
+            </a:r>
+            <a:endParaRPr lang="en-US" sz="2000" dirty="0"/>
+          </a:p>
+        </p:txBody>
+      </p:sp>
+    </p:spTree>
+  </p:cSld>
+  <p:clrMapOvr>
+    <a:masterClrMapping/>
+  </p:clrMapOvr>
+</p:sld>
+</file>
+
+<file path=ppt/slides/slide19.xml><?xml version="1.0" encoding="utf-8"?>
+<p:sld xmlns:a="http://schemas.openxmlformats.org/drawingml/2006/main" xmlns:r="http://schemas.openxmlformats.org/officeDocument/2006/relationships" xmlns:p="http://schemas.openxmlformats.org/presentationml/2006/main">
+  <p:cSld name="Slide 19">
     <p:spTree>
       <p:nvGrpSpPr>
         <p:cNvPr id="1" name=""/>
@@ -6040,7 +7003,7 @@
                 <a:ea typeface="Calibri" pitchFamily="34" charset="-122"/>
                 <a:cs typeface="Calibri" pitchFamily="34" charset="-120"/>
               </a:rPr>
-              <a:t>A receita é bem distribuída entre categorias</a:t>
+              <a:t>Por que a receita parou de crescer</a:t>
             </a:r>
             <a:endParaRPr lang="en-US" sz="2800" dirty="0"/>
           </a:p>
@@ -6048,7 +7011,7 @@
       </p:sp>
       <p:pic>
         <p:nvPicPr>
-          <p:cNvPr id="3" name="Image 0" descr="/sessions/nice-great-mayer/mnt/outputs/pptx_project/assets_simples/chart_03_top_categorias.png">    </p:cNvPr>
+          <p:cNvPr id="3" name="Image 0" descr="/sessions/nice-great-mayer/mnt/outputs/pptx_project/assets_simples/chart_09_vendedores_clientes.png">    </p:cNvPr>
           <p:cNvPicPr>
             <a:picLocks noChangeAspect="1"/>
           </p:cNvPicPr>
@@ -6106,7 +7069,7 @@
                 <a:ea typeface="Calibri" pitchFamily="34" charset="-122"/>
                 <a:cs typeface="Calibri" pitchFamily="34" charset="-120"/>
               </a:rPr>
-              <a:t>São 72 categorias de produto no total.</a:t>
+              <a:t>Em 2018 os vendedores ativos subiram de 968 para 1.266, um crescimento de 31%.</a:t>
             </a:r>
             <a:endParaRPr lang="en-US" sz="1500" dirty="0"/>
           </a:p>
@@ -6127,7 +7090,7 @@
                 <a:ea typeface="Calibri" pitchFamily="34" charset="-122"/>
                 <a:cs typeface="Calibri" pitchFamily="34" charset="-120"/>
               </a:rPr>
-              <a:t>As 5 maiores somam 39% da receita, e as outras 67 dividem o restante.</a:t>
+              <a:t>Os clientes fizeram o contrário: caíram de 7.088 para 6.380, uma queda de 10%.</a:t>
             </a:r>
             <a:endParaRPr lang="en-US" sz="1500" dirty="0"/>
           </a:p>
@@ -6148,7 +7111,28 @@
                 <a:ea typeface="Calibri" pitchFamily="34" charset="-122"/>
                 <a:cs typeface="Calibri" pitchFamily="34" charset="-120"/>
               </a:rPr>
-              <a:t>Isso é positivo, porque a empresa não depende de um único tipo de produto.</a:t>
+              <a:t>Com isso a receita por vendedor caiu 31%, de R$ 1.138 para R$ 788.</a:t>
+            </a:r>
+            <a:endParaRPr lang="en-US" sz="1500" dirty="0"/>
+          </a:p>
+          <a:p>
+            <a:pPr marL="342900" indent="-342900">
+              <a:lnSpc>
+                <a:spcPct val="130000"/>
+              </a:lnSpc>
+              <a:buSzPct val="100000"/>
+              <a:buChar char="•"/>
+            </a:pPr>
+            <a:r>
+              <a:rPr lang="en-US" sz="1500" dirty="0">
+                <a:solidFill>
+                  <a:srgbClr val="404040"/>
+                </a:solidFill>
+                <a:latin typeface="Calibri" pitchFamily="34" charset="0"/>
+                <a:ea typeface="Calibri" pitchFamily="34" charset="-122"/>
+                <a:cs typeface="Calibri" pitchFamily="34" charset="-120"/>
+              </a:rPr>
+              <a:t>O gargalo não é falta de quem venda, é falta de quem compre.</a:t>
             </a:r>
             <a:endParaRPr lang="en-US" sz="1500" dirty="0"/>
           </a:p>
@@ -6187,7 +7171,7 @@
                 <a:ea typeface="Calibri" pitchFamily="34" charset="-122"/>
                 <a:cs typeface="Calibri" pitchFamily="34" charset="-120"/>
               </a:rPr>
-              <a:t>Fonte: base pública Olist, receita por categoria.</a:t>
+              <a:t>Fonte: base pública Olist, clientes e vendedores distintos por mês.</a:t>
             </a:r>
             <a:endParaRPr lang="en-US" sz="1100" dirty="0"/>
           </a:p>

</xml_diff>

<commit_message>
Adiciona capa com ficha tecnica, sumario paginado e cabecalho de pagina
</commit_message>
<xml_diff>
--- a/reports/apresentacao_crescimento_receita.pptx
+++ b/reports/apresentacao_crescimento_receita.pptx
@@ -4,6 +4,9 @@
   <p:sldMasterIdLst>
     <p:sldMasterId id="2147483648" r:id="rId1"/>
   </p:sldMasterIdLst>
+  <p:notesMasterIdLst>
+    <p:notesMasterId r:id="rId21"/>
+  </p:notesMasterIdLst>
   <p:sldIdLst>
     <p:sldId id="256" r:id="rId2"/>
     <p:sldId id="257" r:id="rId3"/>
@@ -25,9 +28,6 @@
     <p:sldId id="273" r:id="rId19"/>
     <p:sldId id="274" r:id="rId20"/>
   </p:sldIdLst>
-  <p:notesMasterIdLst>
-    <p:notesMasterId r:id="rId21"/>
-  </p:notesMasterIdLst>
   <p:sldSz cx="12192000" cy="6858000"/>
   <p:notesSz cx="6858000" cy="12192000"/>
   <p:defaultTextStyle>
@@ -122,7 +122,56 @@
       </a:defRPr>
     </a:lvl9pPr>
   </p:defaultTextStyle>
+  <p:extLst>
+    <p:ext uri="{EFAFB233-063F-42B5-8137-9DF3F51BA10A}">
+      <p15:sldGuideLst xmlns:p15="http://schemas.microsoft.com/office/powerpoint/2012/main"/>
+    </p:ext>
+  </p:extLst>
 </p:presentation>
+</file>
+
+<file path=ppt/changesInfos/changesInfo1.xml><?xml version="1.0" encoding="utf-8"?>
+<pc:chgInfo xmlns:a="http://schemas.openxmlformats.org/drawingml/2006/main" xmlns:r="http://schemas.openxmlformats.org/officeDocument/2006/relationships" xmlns:ac="http://schemas.microsoft.com/office/drawing/2013/main/command" xmlns:pc="http://schemas.microsoft.com/office/powerpoint/2013/main/command">
+  <pc:docChgLst>
+    <pc:chgData name="Evanio Carvalho" userId="a84c28dca2c48ebb" providerId="LiveId" clId="{9951D568-64CE-4441-9351-9161622AC723}"/>
+    <pc:docChg chg="undo custSel modSld">
+      <pc:chgData name="Evanio Carvalho" userId="a84c28dca2c48ebb" providerId="LiveId" clId="{9951D568-64CE-4441-9351-9161622AC723}" dt="2026-08-20T01:32:39.784" v="87" actId="20577"/>
+      <pc:docMkLst>
+        <pc:docMk/>
+      </pc:docMkLst>
+      <pc:sldChg chg="modSp mod">
+        <pc:chgData name="Evanio Carvalho" userId="a84c28dca2c48ebb" providerId="LiveId" clId="{9951D568-64CE-4441-9351-9161622AC723}" dt="2026-08-20T01:30:39.089" v="86" actId="20577"/>
+        <pc:sldMkLst>
+          <pc:docMk/>
+          <pc:sldMk cId="0" sldId="256"/>
+        </pc:sldMkLst>
+        <pc:spChg chg="mod">
+          <ac:chgData name="Evanio Carvalho" userId="a84c28dca2c48ebb" providerId="LiveId" clId="{9951D568-64CE-4441-9351-9161622AC723}" dt="2026-08-20T01:30:39.089" v="86" actId="20577"/>
+          <ac:spMkLst>
+            <pc:docMk/>
+            <pc:sldMk cId="0" sldId="256"/>
+            <ac:spMk id="6" creationId="{00000000-0000-0000-0000-000000000000}"/>
+          </ac:spMkLst>
+        </pc:spChg>
+      </pc:sldChg>
+      <pc:sldChg chg="modSp mod">
+        <pc:chgData name="Evanio Carvalho" userId="a84c28dca2c48ebb" providerId="LiveId" clId="{9951D568-64CE-4441-9351-9161622AC723}" dt="2026-08-20T01:32:39.784" v="87" actId="20577"/>
+        <pc:sldMkLst>
+          <pc:docMk/>
+          <pc:sldMk cId="0" sldId="274"/>
+        </pc:sldMkLst>
+        <pc:spChg chg="mod">
+          <ac:chgData name="Evanio Carvalho" userId="a84c28dca2c48ebb" providerId="LiveId" clId="{9951D568-64CE-4441-9351-9161622AC723}" dt="2026-08-20T01:32:39.784" v="87" actId="20577"/>
+          <ac:spMkLst>
+            <pc:docMk/>
+            <pc:sldMk cId="0" sldId="274"/>
+            <ac:spMk id="3" creationId="{00000000-0000-0000-0000-000000000000}"/>
+          </ac:spMkLst>
+        </pc:spChg>
+      </pc:sldChg>
+    </pc:docChg>
+  </pc:docChgLst>
+</pc:chgInfo>
 </file>
 
 <file path=ppt/notesMasters/notesMaster1.xml><?xml version="1.0" encoding="utf-8"?>
@@ -147,234 +196,10 @@
           <a:chExt cx="0" cy="0"/>
         </a:xfrm>
       </p:grpSpPr>
-      <p:sp>
-        <p:nvSpPr>
-          <p:cNvPr id="2" name="Header Placeholder 1"/>
-          <p:cNvSpPr>
-            <a:spLocks noGrp="1"/>
-          </p:cNvSpPr>
-          <p:nvPr>
-            <p:ph type="hdr" sz="quarter"/>
-          </p:nvPr>
-        </p:nvSpPr>
-        <p:spPr>
-          <a:xfrm>
-            <a:off x="0" y="0"/>
-            <a:ext cx="2971800" cy="458788"/>
-          </a:xfrm>
-          <a:prstGeom prst="rect">
-            <a:avLst/>
-          </a:prstGeom>
-        </p:spPr>
-        <p:txBody>
-          <a:bodyPr vert="horz" lIns="91440" tIns="45720" rIns="91440" bIns="45720" rtlCol="0"/>
-          <a:lstStyle>
-            <a:lvl1pPr algn="l">
-              <a:defRPr sz="1200"/>
-            </a:lvl1pPr>
-          </a:lstStyle>
-          <a:p>
-            <a:endParaRPr lang="en-US"/>
-          </a:p>
-        </p:txBody>
-      </p:sp>
-      <p:sp>
-        <p:nvSpPr>
-          <p:cNvPr id="3" name="Date Placeholder 2"/>
-          <p:cNvSpPr>
-            <a:spLocks noGrp="1"/>
-          </p:cNvSpPr>
-          <p:nvPr>
-            <p:ph type="dt" idx="1"/>
-          </p:nvPr>
-        </p:nvSpPr>
-        <p:spPr>
-          <a:xfrm>
-            <a:off x="3884613" y="0"/>
-            <a:ext cx="2971800" cy="458788"/>
-          </a:xfrm>
-          <a:prstGeom prst="rect">
-            <a:avLst/>
-          </a:prstGeom>
-        </p:spPr>
-        <p:txBody>
-          <a:bodyPr vert="horz" lIns="91440" tIns="45720" rIns="91440" bIns="45720" rtlCol="0"/>
-          <a:lstStyle>
-            <a:lvl1pPr algn="r">
-              <a:defRPr sz="1200"/>
-            </a:lvl1pPr>
-          </a:lstStyle>
-          <a:p>
-            <a:fld id="{5282F153-3F37-0F45-9E97-73ACFA13230C}" type="datetimeFigureOut">
-              <a:rPr lang="en-US"/>
-              <a:t>7/23/19</a:t>
-            </a:fld>
-            <a:endParaRPr lang="en-US"/>
-          </a:p>
-        </p:txBody>
-      </p:sp>
-      <p:sp>
-        <p:nvSpPr>
-          <p:cNvPr id="4" name="Slide Image Placeholder 3"/>
-          <p:cNvSpPr>
-            <a:spLocks noGrp="1" noRot="1" noChangeAspect="1"/>
-          </p:cNvSpPr>
-          <p:nvPr>
-            <p:ph type="sldImg" idx="2"/>
-          </p:nvPr>
-        </p:nvSpPr>
-        <p:spPr>
-          <a:xfrm>
-            <a:off x="685800" y="1143000"/>
-            <a:ext cx="5486400" cy="3086100"/>
-          </a:xfrm>
-          <a:prstGeom prst="rect">
-            <a:avLst/>
-          </a:prstGeom>
-          <a:noFill/>
-          <a:ln w="12700">
-            <a:solidFill>
-              <a:prstClr val="black"/>
-            </a:solidFill>
-          </a:ln>
-        </p:spPr>
-        <p:txBody>
-          <a:bodyPr vert="horz" lIns="91440" tIns="45720" rIns="91440" bIns="45720" rtlCol="0" anchor="ctr"/>
-          <a:lstStyle/>
-          <a:p>
-            <a:endParaRPr lang="en-US"/>
-          </a:p>
-        </p:txBody>
-      </p:sp>
-      <p:sp>
-        <p:nvSpPr>
-          <p:cNvPr id="5" name="Notes Placeholder 4"/>
-          <p:cNvSpPr>
-            <a:spLocks noGrp="1"/>
-          </p:cNvSpPr>
-          <p:nvPr>
-            <p:ph type="body" sz="quarter" idx="3"/>
-          </p:nvPr>
-        </p:nvSpPr>
-        <p:spPr>
-          <a:xfrm>
-            <a:off x="685800" y="4400550"/>
-            <a:ext cx="5486400" cy="3600450"/>
-          </a:xfrm>
-          <a:prstGeom prst="rect">
-            <a:avLst/>
-          </a:prstGeom>
-        </p:spPr>
-        <p:txBody>
-          <a:bodyPr vert="horz" lIns="91440" tIns="45720" rIns="91440" bIns="45720" rtlCol="0"/>
-          <a:lstStyle/>
-          <a:p>
-            <a:pPr lvl="0"/>
-            <a:r>
-              <a:rPr lang="en-US"/>
-              <a:t>Click to edit Master text styles</a:t>
-            </a:r>
-          </a:p>
-          <a:p>
-            <a:pPr lvl="1"/>
-            <a:r>
-              <a:rPr lang="en-US"/>
-              <a:t>Second level</a:t>
-            </a:r>
-          </a:p>
-          <a:p>
-            <a:pPr lvl="2"/>
-            <a:r>
-              <a:rPr lang="en-US"/>
-              <a:t>Third level</a:t>
-            </a:r>
-          </a:p>
-          <a:p>
-            <a:pPr lvl="3"/>
-            <a:r>
-              <a:rPr lang="en-US"/>
-              <a:t>Fourth level</a:t>
-            </a:r>
-          </a:p>
-          <a:p>
-            <a:pPr lvl="4"/>
-            <a:r>
-              <a:rPr lang="en-US"/>
-              <a:t>Fifth level</a:t>
-            </a:r>
-          </a:p>
-        </p:txBody>
-      </p:sp>
-      <p:sp>
-        <p:nvSpPr>
-          <p:cNvPr id="6" name="Footer Placeholder 5"/>
-          <p:cNvSpPr>
-            <a:spLocks noGrp="1"/>
-          </p:cNvSpPr>
-          <p:nvPr>
-            <p:ph type="ftr" sz="quarter" idx="4"/>
-          </p:nvPr>
-        </p:nvSpPr>
-        <p:spPr>
-          <a:xfrm>
-            <a:off x="0" y="8685213"/>
-            <a:ext cx="2971800" cy="458787"/>
-          </a:xfrm>
-          <a:prstGeom prst="rect">
-            <a:avLst/>
-          </a:prstGeom>
-        </p:spPr>
-        <p:txBody>
-          <a:bodyPr vert="horz" lIns="91440" tIns="45720" rIns="91440" bIns="45720" rtlCol="0" anchor="b"/>
-          <a:lstStyle>
-            <a:lvl1pPr algn="l">
-              <a:defRPr sz="1200"/>
-            </a:lvl1pPr>
-          </a:lstStyle>
-          <a:p>
-            <a:endParaRPr lang="en-US"/>
-          </a:p>
-        </p:txBody>
-      </p:sp>
-      <p:sp>
-        <p:nvSpPr>
-          <p:cNvPr id="7" name="Slide Number Placeholder 6"/>
-          <p:cNvSpPr>
-            <a:spLocks noGrp="1"/>
-          </p:cNvSpPr>
-          <p:nvPr>
-            <p:ph type="sldNum" sz="quarter" idx="5"/>
-          </p:nvPr>
-        </p:nvSpPr>
-        <p:spPr>
-          <a:xfrm>
-            <a:off x="3884613" y="8685213"/>
-            <a:ext cx="2971800" cy="458787"/>
-          </a:xfrm>
-          <a:prstGeom prst="rect">
-            <a:avLst/>
-          </a:prstGeom>
-        </p:spPr>
-        <p:txBody>
-          <a:bodyPr vert="horz" lIns="91440" tIns="45720" rIns="91440" bIns="45720" rtlCol="0" anchor="b"/>
-          <a:lstStyle>
-            <a:lvl1pPr algn="r">
-              <a:defRPr sz="1200"/>
-            </a:lvl1pPr>
-          </a:lstStyle>
-          <a:p>
-            <a:fld id="{CE5E9CC1-C706-0F49-92D6-E571CC5EEA8F}" type="slidenum">
-              <a:rPr lang="en-US"/>
-              <a:t>‹#›</a:t>
-            </a:fld>
-            <a:endParaRPr lang="en-US"/>
-          </a:p>
-        </p:txBody>
-      </p:sp>
     </p:spTree>
     <p:extLst>
       <p:ext uri="{BB962C8B-B14F-4D97-AF65-F5344CB8AC3E}">
-        <p14:creationId xmlns:p14="http://schemas.microsoft.com/office/powerpoint/2010/main" val="1024086991"/>
+        <p14:creationId xmlns:p14="http://schemas.microsoft.com/office/powerpoint/2010/main" val="3655326808"/>
       </p:ext>
     </p:extLst>
   </p:cSld>
@@ -518,10 +343,6 @@
           <a:bodyPr/>
           <a:lstStyle/>
           <a:p>
-            <a:r>
-              <a:rPr lang="en-US" dirty="0"/>
-              <a:t/>
-            </a:r>
             <a:endParaRPr lang="en-US" dirty="0"/>
           </a:p>
         </p:txBody>
@@ -606,10 +427,6 @@
           <a:bodyPr/>
           <a:lstStyle/>
           <a:p>
-            <a:r>
-              <a:rPr lang="en-US" dirty="0"/>
-              <a:t/>
-            </a:r>
             <a:endParaRPr lang="en-US" dirty="0"/>
           </a:p>
         </p:txBody>
@@ -694,10 +511,6 @@
           <a:bodyPr/>
           <a:lstStyle/>
           <a:p>
-            <a:r>
-              <a:rPr lang="en-US" dirty="0"/>
-              <a:t/>
-            </a:r>
             <a:endParaRPr lang="en-US" dirty="0"/>
           </a:p>
         </p:txBody>
@@ -782,10 +595,6 @@
           <a:bodyPr/>
           <a:lstStyle/>
           <a:p>
-            <a:r>
-              <a:rPr lang="en-US" dirty="0"/>
-              <a:t/>
-            </a:r>
             <a:endParaRPr lang="en-US" dirty="0"/>
           </a:p>
         </p:txBody>
@@ -870,10 +679,6 @@
           <a:bodyPr/>
           <a:lstStyle/>
           <a:p>
-            <a:r>
-              <a:rPr lang="en-US" dirty="0"/>
-              <a:t/>
-            </a:r>
             <a:endParaRPr lang="en-US" dirty="0"/>
           </a:p>
         </p:txBody>
@@ -958,10 +763,6 @@
           <a:bodyPr/>
           <a:lstStyle/>
           <a:p>
-            <a:r>
-              <a:rPr lang="en-US" dirty="0"/>
-              <a:t/>
-            </a:r>
             <a:endParaRPr lang="en-US" dirty="0"/>
           </a:p>
         </p:txBody>
@@ -1046,10 +847,6 @@
           <a:bodyPr/>
           <a:lstStyle/>
           <a:p>
-            <a:r>
-              <a:rPr lang="en-US" dirty="0"/>
-              <a:t/>
-            </a:r>
             <a:endParaRPr lang="en-US" dirty="0"/>
           </a:p>
         </p:txBody>
@@ -1134,10 +931,6 @@
           <a:bodyPr/>
           <a:lstStyle/>
           <a:p>
-            <a:r>
-              <a:rPr lang="en-US" dirty="0"/>
-              <a:t/>
-            </a:r>
             <a:endParaRPr lang="en-US" dirty="0"/>
           </a:p>
         </p:txBody>
@@ -1222,10 +1015,6 @@
           <a:bodyPr/>
           <a:lstStyle/>
           <a:p>
-            <a:r>
-              <a:rPr lang="en-US" dirty="0"/>
-              <a:t/>
-            </a:r>
             <a:endParaRPr lang="en-US" dirty="0"/>
           </a:p>
         </p:txBody>
@@ -1310,10 +1099,6 @@
           <a:bodyPr/>
           <a:lstStyle/>
           <a:p>
-            <a:r>
-              <a:rPr lang="en-US" dirty="0"/>
-              <a:t/>
-            </a:r>
             <a:endParaRPr lang="en-US" dirty="0"/>
           </a:p>
         </p:txBody>
@@ -1398,10 +1183,6 @@
           <a:bodyPr/>
           <a:lstStyle/>
           <a:p>
-            <a:r>
-              <a:rPr lang="en-US" dirty="0"/>
-              <a:t/>
-            </a:r>
             <a:endParaRPr lang="en-US" dirty="0"/>
           </a:p>
         </p:txBody>
@@ -1486,10 +1267,6 @@
           <a:bodyPr/>
           <a:lstStyle/>
           <a:p>
-            <a:r>
-              <a:rPr lang="en-US" dirty="0"/>
-              <a:t/>
-            </a:r>
             <a:endParaRPr lang="en-US" dirty="0"/>
           </a:p>
         </p:txBody>
@@ -1574,10 +1351,6 @@
           <a:bodyPr/>
           <a:lstStyle/>
           <a:p>
-            <a:r>
-              <a:rPr lang="en-US" dirty="0"/>
-              <a:t/>
-            </a:r>
             <a:endParaRPr lang="en-US" dirty="0"/>
           </a:p>
         </p:txBody>
@@ -1662,10 +1435,6 @@
           <a:bodyPr/>
           <a:lstStyle/>
           <a:p>
-            <a:r>
-              <a:rPr lang="en-US" dirty="0"/>
-              <a:t/>
-            </a:r>
             <a:endParaRPr lang="en-US" dirty="0"/>
           </a:p>
         </p:txBody>
@@ -1750,10 +1519,6 @@
           <a:bodyPr/>
           <a:lstStyle/>
           <a:p>
-            <a:r>
-              <a:rPr lang="en-US" dirty="0"/>
-              <a:t/>
-            </a:r>
             <a:endParaRPr lang="en-US" dirty="0"/>
           </a:p>
         </p:txBody>
@@ -1838,10 +1603,6 @@
           <a:bodyPr/>
           <a:lstStyle/>
           <a:p>
-            <a:r>
-              <a:rPr lang="en-US" dirty="0"/>
-              <a:t/>
-            </a:r>
             <a:endParaRPr lang="en-US" dirty="0"/>
           </a:p>
         </p:txBody>
@@ -1926,10 +1687,6 @@
           <a:bodyPr/>
           <a:lstStyle/>
           <a:p>
-            <a:r>
-              <a:rPr lang="en-US" dirty="0"/>
-              <a:t/>
-            </a:r>
             <a:endParaRPr lang="en-US" dirty="0"/>
           </a:p>
         </p:txBody>
@@ -2014,10 +1771,6 @@
           <a:bodyPr/>
           <a:lstStyle/>
           <a:p>
-            <a:r>
-              <a:rPr lang="en-US" dirty="0"/>
-              <a:t/>
-            </a:r>
             <a:endParaRPr lang="en-US" dirty="0"/>
           </a:p>
         </p:txBody>
@@ -2102,10 +1855,6 @@
           <a:bodyPr/>
           <a:lstStyle/>
           <a:p>
-            <a:r>
-              <a:rPr lang="en-US" dirty="0"/>
-              <a:t/>
-            </a:r>
             <a:endParaRPr lang="en-US" dirty="0"/>
           </a:p>
         </p:txBody>
@@ -2179,6 +1928,11 @@
 <file path=ppt/slideMasters/slideMaster1.xml><?xml version="1.0" encoding="utf-8"?>
 <p:sldMaster xmlns:a="http://schemas.openxmlformats.org/drawingml/2006/main" xmlns:r="http://schemas.openxmlformats.org/officeDocument/2006/relationships" xmlns:p="http://schemas.openxmlformats.org/presentationml/2006/main">
   <p:cSld>
+    <p:bg>
+      <p:bgRef idx="1001">
+        <a:schemeClr val="bg1"/>
+      </p:bgRef>
+    </p:bg>
     <p:spTree>
       <p:nvGrpSpPr>
         <p:cNvPr id="1" name=""/>
@@ -2491,7 +2245,7 @@
           <a:bodyPr wrap="square" rtlCol="0" anchor="ctr"/>
           <a:lstStyle/>
           <a:p>
-            <a:pPr indent="0" marL="0">
+            <a:pPr marL="0" indent="0">
               <a:buNone/>
             </a:pPr>
             <a:r>
@@ -2530,7 +2284,7 @@
           <a:bodyPr wrap="square" rtlCol="0" anchor="ctr"/>
           <a:lstStyle/>
           <a:p>
-            <a:pPr indent="0" marL="0">
+            <a:pPr marL="0" indent="0">
               <a:buNone/>
             </a:pPr>
             <a:r>
@@ -2592,7 +2346,7 @@
           <a:bodyPr wrap="square" rtlCol="0" anchor="ctr"/>
           <a:lstStyle/>
           <a:p>
-            <a:pPr indent="0" marL="0">
+            <a:pPr marL="0" indent="0">
               <a:buNone/>
             </a:pPr>
             <a:r>
@@ -2618,8 +2372,8 @@
         </p:nvSpPr>
         <p:spPr>
           <a:xfrm>
-            <a:off x="731520" y="4434840"/>
-            <a:ext cx="7315200" cy="365760"/>
+            <a:off x="731520" y="4434839"/>
+            <a:ext cx="7315200" cy="1312817"/>
           </a:xfrm>
           <a:prstGeom prst="rect">
             <a:avLst/>
@@ -2631,7 +2385,7 @@
           <a:bodyPr wrap="square" rtlCol="0" anchor="ctr"/>
           <a:lstStyle/>
           <a:p>
-            <a:pPr indent="0" marL="0">
+            <a:pPr marL="0" indent="0">
               <a:buNone/>
             </a:pPr>
             <a:r>
@@ -2643,9 +2397,78 @@
                 <a:ea typeface="Calibri" pitchFamily="34" charset="-122"/>
                 <a:cs typeface="Calibri" pitchFamily="34" charset="-120"/>
               </a:rPr>
+              <a:t>Eduardo </a:t>
+            </a:r>
+            <a:r>
+              <a:rPr lang="en-US" sz="1600" dirty="0" err="1">
+                <a:solidFill>
+                  <a:srgbClr val="404040"/>
+                </a:solidFill>
+                <a:latin typeface="Calibri" pitchFamily="34" charset="0"/>
+                <a:ea typeface="Calibri" pitchFamily="34" charset="-122"/>
+                <a:cs typeface="Calibri" pitchFamily="34" charset="-120"/>
+              </a:rPr>
+              <a:t>Zancanaro</a:t>
+            </a:r>
+            <a:r>
+              <a:rPr lang="en-US" sz="1600" dirty="0">
+                <a:solidFill>
+                  <a:srgbClr val="404040"/>
+                </a:solidFill>
+                <a:latin typeface="Calibri" pitchFamily="34" charset="0"/>
+                <a:ea typeface="Calibri" pitchFamily="34" charset="-122"/>
+                <a:cs typeface="Calibri" pitchFamily="34" charset="-120"/>
+              </a:rPr>
+              <a:t> Vilela</a:t>
+            </a:r>
+          </a:p>
+          <a:p>
+            <a:pPr marL="0" indent="0">
+              <a:buNone/>
+            </a:pPr>
+            <a:r>
+              <a:rPr lang="en-US" sz="1600" dirty="0">
+                <a:solidFill>
+                  <a:srgbClr val="404040"/>
+                </a:solidFill>
+                <a:latin typeface="Calibri" pitchFamily="34" charset="0"/>
+                <a:ea typeface="Calibri" pitchFamily="34" charset="-122"/>
+                <a:cs typeface="Calibri" pitchFamily="34" charset="-120"/>
+              </a:rPr>
               <a:t>Evanio Alves Carvalho</a:t>
             </a:r>
-            <a:endParaRPr lang="en-US" sz="1600" dirty="0"/>
+          </a:p>
+          <a:p>
+            <a:pPr marL="0" indent="0">
+              <a:buNone/>
+            </a:pPr>
+            <a:r>
+              <a:rPr lang="en-US" sz="1600" dirty="0">
+                <a:solidFill>
+                  <a:srgbClr val="404040"/>
+                </a:solidFill>
+                <a:latin typeface="Calibri" pitchFamily="34" charset="0"/>
+                <a:ea typeface="Calibri" pitchFamily="34" charset="-122"/>
+                <a:cs typeface="Calibri" pitchFamily="34" charset="-120"/>
+              </a:rPr>
+              <a:t>Mateus Araujo </a:t>
+            </a:r>
+          </a:p>
+          <a:p>
+            <a:pPr marL="0" indent="0">
+              <a:buNone/>
+            </a:pPr>
+            <a:r>
+              <a:rPr lang="en-US" sz="1600" dirty="0">
+                <a:solidFill>
+                  <a:srgbClr val="404040"/>
+                </a:solidFill>
+                <a:latin typeface="Calibri" pitchFamily="34" charset="0"/>
+                <a:ea typeface="Calibri" pitchFamily="34" charset="-122"/>
+                <a:cs typeface="Calibri" pitchFamily="34" charset="-120"/>
+              </a:rPr>
+              <a:t>Marcela Morillas de S</a:t>
+            </a:r>
           </a:p>
         </p:txBody>
       </p:sp>
@@ -2695,7 +2518,7 @@
           <a:bodyPr wrap="square" rtlCol="0" anchor="ctr"/>
           <a:lstStyle/>
           <a:p>
-            <a:pPr indent="0" marL="0">
+            <a:pPr marL="0" indent="0">
               <a:buNone/>
             </a:pPr>
             <a:r>
@@ -2715,15 +2538,15 @@
       </p:sp>
       <p:pic>
         <p:nvPicPr>
-          <p:cNvPr id="3" name="Image 0" descr="/sessions/nice-great-mayer/mnt/outputs/pptx_project/assets_simples/chart_03_top_categorias.png">    </p:cNvPr>
+          <p:cNvPr id="3" name="Image 0" descr="/sessions/nice-great-mayer/mnt/outputs/pptx_project/assets_simples/chart_03_top_categorias.png"/>
           <p:cNvPicPr>
             <a:picLocks noChangeAspect="1"/>
           </p:cNvPicPr>
           <p:nvPr/>
         </p:nvPicPr>
         <p:blipFill>
-          <a:blip r:embed="rId1"/>
-          <a:srcRect l="0" r="0" t="0" b="0"/>
+          <a:blip r:embed="rId3"/>
+          <a:srcRect/>
           <a:stretch/>
         </p:blipFill>
         <p:spPr>
@@ -2842,7 +2665,7 @@
           <a:bodyPr wrap="square" rtlCol="0" anchor="ctr"/>
           <a:lstStyle/>
           <a:p>
-            <a:pPr indent="0" marL="0">
+            <a:pPr marL="0" indent="0">
               <a:buNone/>
             </a:pPr>
             <a:r>
@@ -2906,7 +2729,7 @@
           <a:bodyPr wrap="square" rtlCol="0" anchor="ctr"/>
           <a:lstStyle/>
           <a:p>
-            <a:pPr indent="0" marL="0">
+            <a:pPr marL="0" indent="0">
               <a:buNone/>
             </a:pPr>
             <a:r>
@@ -2926,15 +2749,15 @@
       </p:sp>
       <p:pic>
         <p:nvPicPr>
-          <p:cNvPr id="3" name="Image 0" descr="/sessions/nice-great-mayer/mnt/outputs/pptx_project/assets_simples/chart_04_top_estados.png">    </p:cNvPr>
+          <p:cNvPr id="3" name="Image 0" descr="/sessions/nice-great-mayer/mnt/outputs/pptx_project/assets_simples/chart_04_top_estados.png"/>
           <p:cNvPicPr>
             <a:picLocks noChangeAspect="1"/>
           </p:cNvPicPr>
           <p:nvPr/>
         </p:nvPicPr>
         <p:blipFill>
-          <a:blip r:embed="rId1"/>
-          <a:srcRect l="0" r="0" t="0" b="0"/>
+          <a:blip r:embed="rId3"/>
+          <a:srcRect/>
           <a:stretch/>
         </p:blipFill>
         <p:spPr>
@@ -3053,7 +2876,7 @@
           <a:bodyPr wrap="square" rtlCol="0" anchor="ctr"/>
           <a:lstStyle/>
           <a:p>
-            <a:pPr indent="0" marL="0">
+            <a:pPr marL="0" indent="0">
               <a:buNone/>
             </a:pPr>
             <a:r>
@@ -3117,7 +2940,7 @@
           <a:bodyPr wrap="square" rtlCol="0" anchor="ctr"/>
           <a:lstStyle/>
           <a:p>
-            <a:pPr indent="0" marL="0">
+            <a:pPr marL="0" indent="0">
               <a:buNone/>
             </a:pPr>
             <a:r>
@@ -3137,15 +2960,15 @@
       </p:sp>
       <p:pic>
         <p:nvPicPr>
-          <p:cNvPr id="3" name="Image 0" descr="/sessions/nice-great-mayer/mnt/outputs/pptx_project/assets_simples/chart_06_top_sellers.png">    </p:cNvPr>
+          <p:cNvPr id="3" name="Image 0" descr="/sessions/nice-great-mayer/mnt/outputs/pptx_project/assets_simples/chart_06_top_sellers.png"/>
           <p:cNvPicPr>
             <a:picLocks noChangeAspect="1"/>
           </p:cNvPicPr>
           <p:nvPr/>
         </p:nvPicPr>
         <p:blipFill>
-          <a:blip r:embed="rId1"/>
-          <a:srcRect l="0" r="0" t="0" b="0"/>
+          <a:blip r:embed="rId3"/>
+          <a:srcRect/>
           <a:stretch/>
         </p:blipFill>
         <p:spPr>
@@ -3264,7 +3087,7 @@
           <a:bodyPr wrap="square" rtlCol="0" anchor="ctr"/>
           <a:lstStyle/>
           <a:p>
-            <a:pPr indent="0" marL="0">
+            <a:pPr marL="0" indent="0">
               <a:buNone/>
             </a:pPr>
             <a:r>
@@ -3328,7 +3151,7 @@
           <a:bodyPr wrap="square" rtlCol="0" anchor="ctr"/>
           <a:lstStyle/>
           <a:p>
-            <a:pPr indent="0" marL="0">
+            <a:pPr marL="0" indent="0">
               <a:buNone/>
             </a:pPr>
             <a:r>
@@ -3348,15 +3171,15 @@
       </p:sp>
       <p:pic>
         <p:nvPicPr>
-          <p:cNvPr id="3" name="Image 0" descr="/sessions/nice-great-mayer/mnt/outputs/pptx_project/assets_simples/chart_10_receita_x_entrega.png">    </p:cNvPr>
+          <p:cNvPr id="3" name="Image 0" descr="/sessions/nice-great-mayer/mnt/outputs/pptx_project/assets_simples/chart_10_receita_x_entrega.png"/>
           <p:cNvPicPr>
             <a:picLocks noChangeAspect="1"/>
           </p:cNvPicPr>
           <p:nvPr/>
         </p:nvPicPr>
         <p:blipFill>
-          <a:blip r:embed="rId1"/>
-          <a:srcRect l="0" r="0" t="0" b="0"/>
+          <a:blip r:embed="rId3"/>
+          <a:srcRect/>
           <a:stretch/>
         </p:blipFill>
         <p:spPr>
@@ -3496,7 +3319,7 @@
           <a:bodyPr wrap="square" rtlCol="0" anchor="ctr"/>
           <a:lstStyle/>
           <a:p>
-            <a:pPr indent="0" marL="0">
+            <a:pPr marL="0" indent="0">
               <a:buNone/>
             </a:pPr>
             <a:r>
@@ -3560,7 +3383,7 @@
           <a:bodyPr wrap="square" rtlCol="0" anchor="ctr"/>
           <a:lstStyle/>
           <a:p>
-            <a:pPr indent="0" marL="0">
+            <a:pPr marL="0" indent="0">
               <a:buNone/>
             </a:pPr>
             <a:r>
@@ -3580,15 +3403,15 @@
       </p:sp>
       <p:pic>
         <p:nvPicPr>
-          <p:cNvPr id="3" name="Image 0" descr="/sessions/nice-great-mayer/mnt/outputs/pptx_project/assets_simples/chart_11_atraso_estado.png">    </p:cNvPr>
+          <p:cNvPr id="3" name="Image 0" descr="/sessions/nice-great-mayer/mnt/outputs/pptx_project/assets_simples/chart_11_atraso_estado.png"/>
           <p:cNvPicPr>
             <a:picLocks noChangeAspect="1"/>
           </p:cNvPicPr>
           <p:nvPr/>
         </p:nvPicPr>
         <p:blipFill>
-          <a:blip r:embed="rId1"/>
-          <a:srcRect l="0" r="0" t="0" b="0"/>
+          <a:blip r:embed="rId3"/>
+          <a:srcRect/>
           <a:stretch/>
         </p:blipFill>
         <p:spPr>
@@ -3728,7 +3551,7 @@
           <a:bodyPr wrap="square" rtlCol="0" anchor="ctr"/>
           <a:lstStyle/>
           <a:p>
-            <a:pPr indent="0" marL="0">
+            <a:pPr marL="0" indent="0">
               <a:buNone/>
             </a:pPr>
             <a:r>
@@ -3792,7 +3615,7 @@
           <a:bodyPr wrap="square" rtlCol="0" anchor="ctr"/>
           <a:lstStyle/>
           <a:p>
-            <a:pPr indent="0" marL="0">
+            <a:pPr marL="0" indent="0">
               <a:buNone/>
             </a:pPr>
             <a:r>
@@ -3812,15 +3635,15 @@
       </p:sp>
       <p:pic>
         <p:nvPicPr>
-          <p:cNvPr id="3" name="Image 0" descr="/sessions/nice-great-mayer/mnt/outputs/pptx_project/assets_simples/chart_12_recompra_atraso.png">    </p:cNvPr>
+          <p:cNvPr id="3" name="Image 0" descr="/sessions/nice-great-mayer/mnt/outputs/pptx_project/assets_simples/chart_12_recompra_atraso.png"/>
           <p:cNvPicPr>
             <a:picLocks noChangeAspect="1"/>
           </p:cNvPicPr>
           <p:nvPr/>
         </p:nvPicPr>
         <p:blipFill>
-          <a:blip r:embed="rId1"/>
-          <a:srcRect l="0" r="0" t="0" b="0"/>
+          <a:blip r:embed="rId3"/>
+          <a:srcRect/>
           <a:stretch/>
         </p:blipFill>
         <p:spPr>
@@ -3960,7 +3783,7 @@
           <a:bodyPr wrap="square" rtlCol="0" anchor="ctr"/>
           <a:lstStyle/>
           <a:p>
-            <a:pPr indent="0" marL="0">
+            <a:pPr marL="0" indent="0">
               <a:buNone/>
             </a:pPr>
             <a:r>
@@ -4024,7 +3847,7 @@
           <a:bodyPr wrap="square" rtlCol="0" anchor="ctr"/>
           <a:lstStyle/>
           <a:p>
-            <a:pPr indent="0" marL="0">
+            <a:pPr marL="0" indent="0">
               <a:buNone/>
             </a:pPr>
             <a:r>
@@ -4044,15 +3867,15 @@
       </p:sp>
       <p:pic>
         <p:nvPicPr>
-          <p:cNvPr id="3" name="Image 0" descr="/sessions/nice-great-mayer/mnt/outputs/pptx_project/assets_simples/chart_08_previsao.png">    </p:cNvPr>
+          <p:cNvPr id="3" name="Image 0" descr="/sessions/nice-great-mayer/mnt/outputs/pptx_project/assets_simples/chart_08_previsao.png"/>
           <p:cNvPicPr>
             <a:picLocks noChangeAspect="1"/>
           </p:cNvPicPr>
           <p:nvPr/>
         </p:nvPicPr>
         <p:blipFill>
-          <a:blip r:embed="rId1"/>
-          <a:srcRect l="0" r="0" t="0" b="0"/>
+          <a:blip r:embed="rId3"/>
+          <a:srcRect/>
           <a:stretch/>
         </p:blipFill>
         <p:spPr>
@@ -4192,7 +4015,7 @@
           <a:bodyPr wrap="square" rtlCol="0" anchor="ctr"/>
           <a:lstStyle/>
           <a:p>
-            <a:pPr indent="0" marL="0">
+            <a:pPr marL="0" indent="0">
               <a:buNone/>
             </a:pPr>
             <a:r>
@@ -4256,7 +4079,7 @@
           <a:bodyPr wrap="square" rtlCol="0" anchor="ctr"/>
           <a:lstStyle/>
           <a:p>
-            <a:pPr indent="0" marL="0">
+            <a:pPr marL="0" indent="0">
               <a:buNone/>
             </a:pPr>
             <a:r>
@@ -4447,7 +4270,7 @@
           <a:bodyPr wrap="square" rtlCol="0" anchor="ctr"/>
           <a:lstStyle/>
           <a:p>
-            <a:pPr indent="0" marL="0">
+            <a:pPr marL="0" indent="0">
               <a:buNone/>
             </a:pPr>
             <a:r>
@@ -4617,7 +4440,7 @@
           <a:bodyPr wrap="square" rtlCol="0" anchor="ctr"/>
           <a:lstStyle/>
           <a:p>
-            <a:pPr algn="ctr" indent="0" marL="0">
+            <a:pPr marL="0" indent="0" algn="ctr">
               <a:buNone/>
             </a:pPr>
             <a:r>
@@ -4656,7 +4479,7 @@
           <a:bodyPr wrap="square" rtlCol="0" anchor="ctr"/>
           <a:lstStyle/>
           <a:p>
-            <a:pPr algn="ctr" indent="0" marL="0">
+            <a:pPr marL="0" indent="0" algn="ctr">
               <a:buNone/>
             </a:pPr>
             <a:r>
@@ -4668,7 +4491,7 @@
                 <a:ea typeface="Calibri" pitchFamily="34" charset="-122"/>
                 <a:cs typeface="Calibri" pitchFamily="34" charset="-120"/>
               </a:rPr>
-              <a:t>Evanio Alves Carvalho | Tech Challenge Fase 1</a:t>
+              <a:t>Tech Challenge Fase 1</a:t>
             </a:r>
             <a:endParaRPr lang="en-US" sz="1600" dirty="0"/>
           </a:p>
@@ -4720,7 +4543,7 @@
           <a:bodyPr wrap="square" rtlCol="0" anchor="ctr"/>
           <a:lstStyle/>
           <a:p>
-            <a:pPr indent="0" marL="0">
+            <a:pPr marL="0" indent="0">
               <a:buNone/>
             </a:pPr>
             <a:r>
@@ -4911,7 +4734,7 @@
           <a:bodyPr wrap="square" rtlCol="0" anchor="ctr"/>
           <a:lstStyle/>
           <a:p>
-            <a:pPr indent="0" marL="0">
+            <a:pPr marL="0" indent="0">
               <a:buNone/>
             </a:pPr>
             <a:r>
@@ -5102,7 +4925,7 @@
           <a:bodyPr wrap="square" rtlCol="0" anchor="ctr"/>
           <a:lstStyle/>
           <a:p>
-            <a:pPr indent="0" marL="0">
+            <a:pPr marL="0" indent="0">
               <a:buNone/>
             </a:pPr>
             <a:r>
@@ -5136,15 +4959,27 @@
         </p:nvGraphicFramePr>
         <p:xfrm>
           <a:off x="1463040" y="1645920"/>
-          <a:ext cx="9144000" cy="914400"/>
+          <a:ext cx="9144000" cy="3520440"/>
         </p:xfrm>
         <a:graphic>
           <a:graphicData uri="http://schemas.openxmlformats.org/drawingml/2006/table">
             <a:tbl>
               <a:tblPr/>
               <a:tblGrid>
-                <a:gridCol w="4572000"/>
-                <a:gridCol w="4572000"/>
+                <a:gridCol w="4572000">
+                  <a:extLst>
+                    <a:ext uri="{9D8B030D-6E8A-4147-A177-3AD203B41FA5}">
+                      <a16:colId xmlns:a16="http://schemas.microsoft.com/office/drawing/2014/main" val="20000"/>
+                    </a:ext>
+                  </a:extLst>
+                </a:gridCol>
+                <a:gridCol w="4572000">
+                  <a:extLst>
+                    <a:ext uri="{9D8B030D-6E8A-4147-A177-3AD203B41FA5}">
+                      <a16:colId xmlns:a16="http://schemas.microsoft.com/office/drawing/2014/main" val="20001"/>
+                    </a:ext>
+                  </a:extLst>
+                </a:gridCol>
               </a:tblGrid>
               <a:tr h="502920">
                 <a:tc>
@@ -5152,7 +4987,7 @@
                     <a:bodyPr/>
                     <a:lstStyle/>
                     <a:p>
-                      <a:pPr indent="0" marL="0">
+                      <a:pPr marL="0" indent="0">
                         <a:buNone/>
                       </a:pPr>
                       <a:r>
@@ -5173,7 +5008,7 @@
                       </a:endParaRPr>
                     </a:p>
                   </a:txBody>
-                  <a:tcPr marL="91440" marR="91440" marT="45720" marB="45720">
+                  <a:tcPr>
                     <a:lnL w="12700" cap="flat" cmpd="sng" algn="ctr">
                       <a:solidFill>
                         <a:srgbClr val="D9D9D9"/>
@@ -5220,7 +5055,7 @@
                     <a:bodyPr/>
                     <a:lstStyle/>
                     <a:p>
-                      <a:pPr indent="0" marL="0">
+                      <a:pPr marL="0" indent="0">
                         <a:buNone/>
                       </a:pPr>
                       <a:r>
@@ -5241,7 +5076,7 @@
                       </a:endParaRPr>
                     </a:p>
                   </a:txBody>
-                  <a:tcPr marL="91440" marR="91440" marT="45720" marB="45720">
+                  <a:tcPr>
                     <a:lnL w="12700" cap="flat" cmpd="sng" algn="ctr">
                       <a:solidFill>
                         <a:srgbClr val="D9D9D9"/>
@@ -5283,6 +5118,11 @@
                     </a:solidFill>
                   </a:tcPr>
                 </a:tc>
+                <a:extLst>
+                  <a:ext uri="{0D108BD9-81ED-4DB2-BD59-A6C34878D82A}">
+                    <a16:rowId xmlns:a16="http://schemas.microsoft.com/office/drawing/2014/main" val="10000"/>
+                  </a:ext>
+                </a:extLst>
               </a:tr>
               <a:tr h="502920">
                 <a:tc>
@@ -5290,7 +5130,7 @@
                     <a:bodyPr/>
                     <a:lstStyle/>
                     <a:p>
-                      <a:pPr indent="0" marL="0">
+                      <a:pPr marL="0" indent="0">
                         <a:buNone/>
                       </a:pPr>
                       <a:r>
@@ -5311,7 +5151,7 @@
                       </a:endParaRPr>
                     </a:p>
                   </a:txBody>
-                  <a:tcPr marL="91440" marR="91440" marT="45720" marB="45720">
+                  <a:tcPr>
                     <a:lnL w="12700" cap="flat" cmpd="sng" algn="ctr">
                       <a:solidFill>
                         <a:srgbClr val="D9D9D9"/>
@@ -5355,7 +5195,7 @@
                     <a:bodyPr/>
                     <a:lstStyle/>
                     <a:p>
-                      <a:pPr indent="0" marL="0">
+                      <a:pPr marL="0" indent="0">
                         <a:buNone/>
                       </a:pPr>
                       <a:r>
@@ -5376,7 +5216,7 @@
                       </a:endParaRPr>
                     </a:p>
                   </a:txBody>
-                  <a:tcPr marL="91440" marR="91440" marT="45720" marB="45720">
+                  <a:tcPr>
                     <a:lnL w="12700" cap="flat" cmpd="sng" algn="ctr">
                       <a:solidFill>
                         <a:srgbClr val="D9D9D9"/>
@@ -5415,6 +5255,11 @@
                     </a:lnB>
                   </a:tcPr>
                 </a:tc>
+                <a:extLst>
+                  <a:ext uri="{0D108BD9-81ED-4DB2-BD59-A6C34878D82A}">
+                    <a16:rowId xmlns:a16="http://schemas.microsoft.com/office/drawing/2014/main" val="10001"/>
+                  </a:ext>
+                </a:extLst>
               </a:tr>
               <a:tr h="502920">
                 <a:tc>
@@ -5422,7 +5267,7 @@
                     <a:bodyPr/>
                     <a:lstStyle/>
                     <a:p>
-                      <a:pPr indent="0" marL="0">
+                      <a:pPr marL="0" indent="0">
                         <a:buNone/>
                       </a:pPr>
                       <a:r>
@@ -5443,7 +5288,7 @@
                       </a:endParaRPr>
                     </a:p>
                   </a:txBody>
-                  <a:tcPr marL="91440" marR="91440" marT="45720" marB="45720">
+                  <a:tcPr>
                     <a:lnL w="12700" cap="flat" cmpd="sng" algn="ctr">
                       <a:solidFill>
                         <a:srgbClr val="D9D9D9"/>
@@ -5487,7 +5332,7 @@
                     <a:bodyPr/>
                     <a:lstStyle/>
                     <a:p>
-                      <a:pPr indent="0" marL="0">
+                      <a:pPr marL="0" indent="0">
                         <a:buNone/>
                       </a:pPr>
                       <a:r>
@@ -5508,7 +5353,7 @@
                       </a:endParaRPr>
                     </a:p>
                   </a:txBody>
-                  <a:tcPr marL="91440" marR="91440" marT="45720" marB="45720">
+                  <a:tcPr>
                     <a:lnL w="12700" cap="flat" cmpd="sng" algn="ctr">
                       <a:solidFill>
                         <a:srgbClr val="D9D9D9"/>
@@ -5547,6 +5392,11 @@
                     </a:lnB>
                   </a:tcPr>
                 </a:tc>
+                <a:extLst>
+                  <a:ext uri="{0D108BD9-81ED-4DB2-BD59-A6C34878D82A}">
+                    <a16:rowId xmlns:a16="http://schemas.microsoft.com/office/drawing/2014/main" val="10002"/>
+                  </a:ext>
+                </a:extLst>
               </a:tr>
               <a:tr h="502920">
                 <a:tc>
@@ -5554,7 +5404,7 @@
                     <a:bodyPr/>
                     <a:lstStyle/>
                     <a:p>
-                      <a:pPr indent="0" marL="0">
+                      <a:pPr marL="0" indent="0">
                         <a:buNone/>
                       </a:pPr>
                       <a:r>
@@ -5575,7 +5425,7 @@
                       </a:endParaRPr>
                     </a:p>
                   </a:txBody>
-                  <a:tcPr marL="91440" marR="91440" marT="45720" marB="45720">
+                  <a:tcPr>
                     <a:lnL w="12700" cap="flat" cmpd="sng" algn="ctr">
                       <a:solidFill>
                         <a:srgbClr val="D9D9D9"/>
@@ -5619,7 +5469,7 @@
                     <a:bodyPr/>
                     <a:lstStyle/>
                     <a:p>
-                      <a:pPr indent="0" marL="0">
+                      <a:pPr marL="0" indent="0">
                         <a:buNone/>
                       </a:pPr>
                       <a:r>
@@ -5640,7 +5490,7 @@
                       </a:endParaRPr>
                     </a:p>
                   </a:txBody>
-                  <a:tcPr marL="91440" marR="91440" marT="45720" marB="45720">
+                  <a:tcPr>
                     <a:lnL w="12700" cap="flat" cmpd="sng" algn="ctr">
                       <a:solidFill>
                         <a:srgbClr val="D9D9D9"/>
@@ -5679,6 +5529,11 @@
                     </a:lnB>
                   </a:tcPr>
                 </a:tc>
+                <a:extLst>
+                  <a:ext uri="{0D108BD9-81ED-4DB2-BD59-A6C34878D82A}">
+                    <a16:rowId xmlns:a16="http://schemas.microsoft.com/office/drawing/2014/main" val="10003"/>
+                  </a:ext>
+                </a:extLst>
               </a:tr>
               <a:tr h="502920">
                 <a:tc>
@@ -5686,7 +5541,7 @@
                     <a:bodyPr/>
                     <a:lstStyle/>
                     <a:p>
-                      <a:pPr indent="0" marL="0">
+                      <a:pPr marL="0" indent="0">
                         <a:buNone/>
                       </a:pPr>
                       <a:r>
@@ -5707,7 +5562,7 @@
                       </a:endParaRPr>
                     </a:p>
                   </a:txBody>
-                  <a:tcPr marL="91440" marR="91440" marT="45720" marB="45720">
+                  <a:tcPr>
                     <a:lnL w="12700" cap="flat" cmpd="sng" algn="ctr">
                       <a:solidFill>
                         <a:srgbClr val="D9D9D9"/>
@@ -5751,7 +5606,7 @@
                     <a:bodyPr/>
                     <a:lstStyle/>
                     <a:p>
-                      <a:pPr indent="0" marL="0">
+                      <a:pPr marL="0" indent="0">
                         <a:buNone/>
                       </a:pPr>
                       <a:r>
@@ -5772,7 +5627,7 @@
                       </a:endParaRPr>
                     </a:p>
                   </a:txBody>
-                  <a:tcPr marL="91440" marR="91440" marT="45720" marB="45720">
+                  <a:tcPr>
                     <a:lnL w="12700" cap="flat" cmpd="sng" algn="ctr">
                       <a:solidFill>
                         <a:srgbClr val="D9D9D9"/>
@@ -5811,6 +5666,11 @@
                     </a:lnB>
                   </a:tcPr>
                 </a:tc>
+                <a:extLst>
+                  <a:ext uri="{0D108BD9-81ED-4DB2-BD59-A6C34878D82A}">
+                    <a16:rowId xmlns:a16="http://schemas.microsoft.com/office/drawing/2014/main" val="10004"/>
+                  </a:ext>
+                </a:extLst>
               </a:tr>
               <a:tr h="502920">
                 <a:tc>
@@ -5818,7 +5678,7 @@
                     <a:bodyPr/>
                     <a:lstStyle/>
                     <a:p>
-                      <a:pPr indent="0" marL="0">
+                      <a:pPr marL="0" indent="0">
                         <a:buNone/>
                       </a:pPr>
                       <a:r>
@@ -5839,7 +5699,7 @@
                       </a:endParaRPr>
                     </a:p>
                   </a:txBody>
-                  <a:tcPr marL="91440" marR="91440" marT="45720" marB="45720">
+                  <a:tcPr>
                     <a:lnL w="12700" cap="flat" cmpd="sng" algn="ctr">
                       <a:solidFill>
                         <a:srgbClr val="D9D9D9"/>
@@ -5883,7 +5743,7 @@
                     <a:bodyPr/>
                     <a:lstStyle/>
                     <a:p>
-                      <a:pPr indent="0" marL="0">
+                      <a:pPr marL="0" indent="0">
                         <a:buNone/>
                       </a:pPr>
                       <a:r>
@@ -5904,7 +5764,7 @@
                       </a:endParaRPr>
                     </a:p>
                   </a:txBody>
-                  <a:tcPr marL="91440" marR="91440" marT="45720" marB="45720">
+                  <a:tcPr>
                     <a:lnL w="12700" cap="flat" cmpd="sng" algn="ctr">
                       <a:solidFill>
                         <a:srgbClr val="D9D9D9"/>
@@ -5943,6 +5803,11 @@
                     </a:lnB>
                   </a:tcPr>
                 </a:tc>
+                <a:extLst>
+                  <a:ext uri="{0D108BD9-81ED-4DB2-BD59-A6C34878D82A}">
+                    <a16:rowId xmlns:a16="http://schemas.microsoft.com/office/drawing/2014/main" val="10005"/>
+                  </a:ext>
+                </a:extLst>
               </a:tr>
               <a:tr h="502920">
                 <a:tc>
@@ -5950,7 +5815,7 @@
                     <a:bodyPr/>
                     <a:lstStyle/>
                     <a:p>
-                      <a:pPr indent="0" marL="0">
+                      <a:pPr marL="0" indent="0">
                         <a:buNone/>
                       </a:pPr>
                       <a:r>
@@ -5971,7 +5836,7 @@
                       </a:endParaRPr>
                     </a:p>
                   </a:txBody>
-                  <a:tcPr marL="91440" marR="91440" marT="45720" marB="45720">
+                  <a:tcPr>
                     <a:lnL w="12700" cap="flat" cmpd="sng" algn="ctr">
                       <a:solidFill>
                         <a:srgbClr val="D9D9D9"/>
@@ -6015,7 +5880,7 @@
                     <a:bodyPr/>
                     <a:lstStyle/>
                     <a:p>
-                      <a:pPr indent="0" marL="0">
+                      <a:pPr marL="0" indent="0">
                         <a:buNone/>
                       </a:pPr>
                       <a:r>
@@ -6036,7 +5901,7 @@
                       </a:endParaRPr>
                     </a:p>
                   </a:txBody>
-                  <a:tcPr marL="91440" marR="91440" marT="45720" marB="45720">
+                  <a:tcPr>
                     <a:lnL w="12700" cap="flat" cmpd="sng" algn="ctr">
                       <a:solidFill>
                         <a:srgbClr val="D9D9D9"/>
@@ -6075,6 +5940,11 @@
                     </a:lnB>
                   </a:tcPr>
                 </a:tc>
+                <a:extLst>
+                  <a:ext uri="{0D108BD9-81ED-4DB2-BD59-A6C34878D82A}">
+                    <a16:rowId xmlns:a16="http://schemas.microsoft.com/office/drawing/2014/main" val="10006"/>
+                  </a:ext>
+                </a:extLst>
               </a:tr>
             </a:tbl>
           </a:graphicData>
@@ -6126,7 +5996,7 @@
           <a:bodyPr wrap="square" rtlCol="0" anchor="ctr"/>
           <a:lstStyle/>
           <a:p>
-            <a:pPr indent="0" marL="0">
+            <a:pPr marL="0" indent="0">
               <a:buNone/>
             </a:pPr>
             <a:r>
@@ -6146,15 +6016,15 @@
       </p:sp>
       <p:pic>
         <p:nvPicPr>
-          <p:cNvPr id="3" name="Image 0" descr="/sessions/nice-great-mayer/mnt/outputs/pptx_project/assets_simples/chart_00_serie_completa.png">    </p:cNvPr>
+          <p:cNvPr id="3" name="Image 0" descr="/sessions/nice-great-mayer/mnt/outputs/pptx_project/assets_simples/chart_00_serie_completa.png"/>
           <p:cNvPicPr>
             <a:picLocks noChangeAspect="1"/>
           </p:cNvPicPr>
           <p:nvPr/>
         </p:nvPicPr>
         <p:blipFill>
-          <a:blip r:embed="rId1"/>
-          <a:srcRect l="0" r="0" t="0" b="0"/>
+          <a:blip r:embed="rId3"/>
+          <a:srcRect/>
           <a:stretch/>
         </p:blipFill>
         <p:spPr>
@@ -6294,7 +6164,7 @@
           <a:bodyPr wrap="square" rtlCol="0" anchor="ctr"/>
           <a:lstStyle/>
           <a:p>
-            <a:pPr indent="0" marL="0">
+            <a:pPr marL="0" indent="0">
               <a:buNone/>
             </a:pPr>
             <a:r>
@@ -6358,7 +6228,7 @@
           <a:bodyPr wrap="square" rtlCol="0" anchor="ctr"/>
           <a:lstStyle/>
           <a:p>
-            <a:pPr indent="0" marL="0">
+            <a:pPr marL="0" indent="0">
               <a:buNone/>
             </a:pPr>
             <a:r>
@@ -6378,15 +6248,15 @@
       </p:sp>
       <p:pic>
         <p:nvPicPr>
-          <p:cNvPr id="3" name="Image 0" descr="/sessions/nice-great-mayer/mnt/outputs/pptx_project/assets_simples/chart_01_evolucao_mensal.png">    </p:cNvPr>
+          <p:cNvPr id="3" name="Image 0" descr="/sessions/nice-great-mayer/mnt/outputs/pptx_project/assets_simples/chart_01_evolucao_mensal.png"/>
           <p:cNvPicPr>
             <a:picLocks noChangeAspect="1"/>
           </p:cNvPicPr>
           <p:nvPr/>
         </p:nvPicPr>
         <p:blipFill>
-          <a:blip r:embed="rId1"/>
-          <a:srcRect l="0" r="0" t="0" b="0"/>
+          <a:blip r:embed="rId3"/>
+          <a:srcRect/>
           <a:stretch/>
         </p:blipFill>
         <p:spPr>
@@ -6505,7 +6375,7 @@
           <a:bodyPr wrap="square" rtlCol="0" anchor="ctr"/>
           <a:lstStyle/>
           <a:p>
-            <a:pPr indent="0" marL="0">
+            <a:pPr marL="0" indent="0">
               <a:buNone/>
             </a:pPr>
             <a:r>
@@ -6569,7 +6439,7 @@
           <a:bodyPr wrap="square" rtlCol="0" anchor="ctr"/>
           <a:lstStyle/>
           <a:p>
-            <a:pPr indent="0" marL="0">
+            <a:pPr marL="0" indent="0">
               <a:buNone/>
             </a:pPr>
             <a:r>
@@ -6589,15 +6459,15 @@
       </p:sp>
       <p:pic>
         <p:nvPicPr>
-          <p:cNvPr id="3" name="Image 0" descr="/sessions/nice-great-mayer/mnt/outputs/pptx_project/assets_simples/chart_07_black_friday.png">    </p:cNvPr>
+          <p:cNvPr id="3" name="Image 0" descr="/sessions/nice-great-mayer/mnt/outputs/pptx_project/assets_simples/chart_07_black_friday.png"/>
           <p:cNvPicPr>
             <a:picLocks noChangeAspect="1"/>
           </p:cNvPicPr>
           <p:nvPr/>
         </p:nvPicPr>
         <p:blipFill>
-          <a:blip r:embed="rId1"/>
-          <a:srcRect l="0" r="0" t="0" b="0"/>
+          <a:blip r:embed="rId3"/>
+          <a:srcRect/>
           <a:stretch/>
         </p:blipFill>
         <p:spPr>
@@ -6716,7 +6586,7 @@
           <a:bodyPr wrap="square" rtlCol="0" anchor="ctr"/>
           <a:lstStyle/>
           <a:p>
-            <a:pPr indent="0" marL="0">
+            <a:pPr marL="0" indent="0">
               <a:buNone/>
             </a:pPr>
             <a:r>
@@ -6780,7 +6650,7 @@
           <a:bodyPr wrap="square" rtlCol="0" anchor="ctr"/>
           <a:lstStyle/>
           <a:p>
-            <a:pPr indent="0" marL="0">
+            <a:pPr marL="0" indent="0">
               <a:buNone/>
             </a:pPr>
             <a:r>
@@ -6800,15 +6670,15 @@
       </p:sp>
       <p:pic>
         <p:nvPicPr>
-          <p:cNvPr id="3" name="Image 0" descr="/sessions/nice-great-mayer/mnt/outputs/pptx_project/assets_simples/chart_02_ticket_medio.png">    </p:cNvPr>
+          <p:cNvPr id="3" name="Image 0" descr="/sessions/nice-great-mayer/mnt/outputs/pptx_project/assets_simples/chart_02_ticket_medio.png"/>
           <p:cNvPicPr>
             <a:picLocks noChangeAspect="1"/>
           </p:cNvPicPr>
           <p:nvPr/>
         </p:nvPicPr>
         <p:blipFill>
-          <a:blip r:embed="rId1"/>
-          <a:srcRect l="0" r="0" t="0" b="0"/>
+          <a:blip r:embed="rId3"/>
+          <a:srcRect/>
           <a:stretch/>
         </p:blipFill>
         <p:spPr>
@@ -6927,7 +6797,7 @@
           <a:bodyPr wrap="square" rtlCol="0" anchor="ctr"/>
           <a:lstStyle/>
           <a:p>
-            <a:pPr indent="0" marL="0">
+            <a:pPr marL="0" indent="0">
               <a:buNone/>
             </a:pPr>
             <a:r>
@@ -6991,7 +6861,7 @@
           <a:bodyPr wrap="square" rtlCol="0" anchor="ctr"/>
           <a:lstStyle/>
           <a:p>
-            <a:pPr indent="0" marL="0">
+            <a:pPr marL="0" indent="0">
               <a:buNone/>
             </a:pPr>
             <a:r>
@@ -7011,15 +6881,15 @@
       </p:sp>
       <p:pic>
         <p:nvPicPr>
-          <p:cNvPr id="3" name="Image 0" descr="/sessions/nice-great-mayer/mnt/outputs/pptx_project/assets_simples/chart_09_vendedores_clientes.png">    </p:cNvPr>
+          <p:cNvPr id="3" name="Image 0" descr="/sessions/nice-great-mayer/mnt/outputs/pptx_project/assets_simples/chart_09_vendedores_clientes.png"/>
           <p:cNvPicPr>
             <a:picLocks noChangeAspect="1"/>
           </p:cNvPicPr>
           <p:nvPr/>
         </p:nvPicPr>
         <p:blipFill>
-          <a:blip r:embed="rId1"/>
-          <a:srcRect l="0" r="0" t="0" b="0"/>
+          <a:blip r:embed="rId3"/>
+          <a:srcRect/>
           <a:stretch/>
         </p:blipFill>
         <p:spPr>
@@ -7159,7 +7029,7 @@
           <a:bodyPr wrap="square" rtlCol="0" anchor="ctr"/>
           <a:lstStyle/>
           <a:p>
-            <a:pPr indent="0" marL="0">
+            <a:pPr marL="0" indent="0">
               <a:buNone/>
             </a:pPr>
             <a:r>
@@ -7478,4 +7348,319 @@
     </a:ext>
   </a:extLst>
 </a:theme>
+</file>
+
+<file path=ppt/theme/theme2.xml><?xml version="1.0" encoding="utf-8"?>
+<a:theme xmlns:a="http://schemas.openxmlformats.org/drawingml/2006/main" name="Tema do Office">
+  <a:themeElements>
+    <a:clrScheme name="Office">
+      <a:dk1>
+        <a:sysClr val="windowText" lastClr="000000"/>
+      </a:dk1>
+      <a:lt1>
+        <a:sysClr val="window" lastClr="FFFFFF"/>
+      </a:lt1>
+      <a:dk2>
+        <a:srgbClr val="0E2841"/>
+      </a:dk2>
+      <a:lt2>
+        <a:srgbClr val="E8E8E8"/>
+      </a:lt2>
+      <a:accent1>
+        <a:srgbClr val="156082"/>
+      </a:accent1>
+      <a:accent2>
+        <a:srgbClr val="E97132"/>
+      </a:accent2>
+      <a:accent3>
+        <a:srgbClr val="196B24"/>
+      </a:accent3>
+      <a:accent4>
+        <a:srgbClr val="0F9ED5"/>
+      </a:accent4>
+      <a:accent5>
+        <a:srgbClr val="A02B93"/>
+      </a:accent5>
+      <a:accent6>
+        <a:srgbClr val="4EA72E"/>
+      </a:accent6>
+      <a:hlink>
+        <a:srgbClr val="467886"/>
+      </a:hlink>
+      <a:folHlink>
+        <a:srgbClr val="96607D"/>
+      </a:folHlink>
+    </a:clrScheme>
+    <a:fontScheme name="Office">
+      <a:majorFont>
+        <a:latin typeface="Aptos Display" panose="02110004020202020204"/>
+        <a:ea typeface=""/>
+        <a:cs typeface=""/>
+        <a:font script="Jpan" typeface="游ゴシック Light"/>
+        <a:font script="Hang" typeface="맑은 고딕"/>
+        <a:font script="Hans" typeface="等线 Light"/>
+        <a:font script="Hant" typeface="新細明體"/>
+        <a:font script="Arab" typeface="Times New Roman"/>
+        <a:font script="Hebr" typeface="Times New Roman"/>
+        <a:font script="Thai" typeface="Angsana New"/>
+        <a:font script="Ethi" typeface="Nyala"/>
+        <a:font script="Beng" typeface="Vrinda"/>
+        <a:font script="Gujr" typeface="Shruti"/>
+        <a:font script="Khmr" typeface="MoolBoran"/>
+        <a:font script="Knda" typeface="Tunga"/>
+        <a:font script="Guru" typeface="Raavi"/>
+        <a:font script="Cans" typeface="Euphemia"/>
+        <a:font script="Cher" typeface="Plantagenet Cherokee"/>
+        <a:font script="Yiii" typeface="Microsoft Yi Baiti"/>
+        <a:font script="Tibt" typeface="Microsoft Himalaya"/>
+        <a:font script="Thaa" typeface="MV Boli"/>
+        <a:font script="Deva" typeface="Mangal"/>
+        <a:font script="Telu" typeface="Gautami"/>
+        <a:font script="Taml" typeface="Latha"/>
+        <a:font script="Syrc" typeface="Estrangelo Edessa"/>
+        <a:font script="Orya" typeface="Kalinga"/>
+        <a:font script="Mlym" typeface="Kartika"/>
+        <a:font script="Laoo" typeface="DokChampa"/>
+        <a:font script="Sinh" typeface="Iskoola Pota"/>
+        <a:font script="Mong" typeface="Mongolian Baiti"/>
+        <a:font script="Viet" typeface="Times New Roman"/>
+        <a:font script="Uigh" typeface="Microsoft Uighur"/>
+        <a:font script="Geor" typeface="Sylfaen"/>
+        <a:font script="Armn" typeface="Arial"/>
+        <a:font script="Bugi" typeface="Leelawadee UI"/>
+        <a:font script="Bopo" typeface="Microsoft JhengHei"/>
+        <a:font script="Java" typeface="Javanese Text"/>
+        <a:font script="Lisu" typeface="Segoe UI"/>
+        <a:font script="Mymr" typeface="Myanmar Text"/>
+        <a:font script="Nkoo" typeface="Ebrima"/>
+        <a:font script="Olck" typeface="Nirmala UI"/>
+        <a:font script="Osma" typeface="Ebrima"/>
+        <a:font script="Phag" typeface="Phagspa"/>
+        <a:font script="Syrn" typeface="Estrangelo Edessa"/>
+        <a:font script="Syrj" typeface="Estrangelo Edessa"/>
+        <a:font script="Syre" typeface="Estrangelo Edessa"/>
+        <a:font script="Sora" typeface="Nirmala UI"/>
+        <a:font script="Tale" typeface="Microsoft Tai Le"/>
+        <a:font script="Talu" typeface="Microsoft New Tai Lue"/>
+        <a:font script="Tfng" typeface="Ebrima"/>
+      </a:majorFont>
+      <a:minorFont>
+        <a:latin typeface="Aptos" panose="02110004020202020204"/>
+        <a:ea typeface=""/>
+        <a:cs typeface=""/>
+        <a:font script="Jpan" typeface="游ゴシック"/>
+        <a:font script="Hang" typeface="맑은 고딕"/>
+        <a:font script="Hans" typeface="等线"/>
+        <a:font script="Hant" typeface="新細明體"/>
+        <a:font script="Arab" typeface="Arial"/>
+        <a:font script="Hebr" typeface="Arial"/>
+        <a:font script="Thai" typeface="Cordia New"/>
+        <a:font script="Ethi" typeface="Nyala"/>
+        <a:font script="Beng" typeface="Vrinda"/>
+        <a:font script="Gujr" typeface="Shruti"/>
+        <a:font script="Khmr" typeface="DaunPenh"/>
+        <a:font script="Knda" typeface="Tunga"/>
+        <a:font script="Guru" typeface="Raavi"/>
+        <a:font script="Cans" typeface="Euphemia"/>
+        <a:font script="Cher" typeface="Plantagenet Cherokee"/>
+        <a:font script="Yiii" typeface="Microsoft Yi Baiti"/>
+        <a:font script="Tibt" typeface="Microsoft Himalaya"/>
+        <a:font script="Thaa" typeface="MV Boli"/>
+        <a:font script="Deva" typeface="Mangal"/>
+        <a:font script="Telu" typeface="Gautami"/>
+        <a:font script="Taml" typeface="Latha"/>
+        <a:font script="Syrc" typeface="Estrangelo Edessa"/>
+        <a:font script="Orya" typeface="Kalinga"/>
+        <a:font script="Mlym" typeface="Kartika"/>
+        <a:font script="Laoo" typeface="DokChampa"/>
+        <a:font script="Sinh" typeface="Iskoola Pota"/>
+        <a:font script="Mong" typeface="Mongolian Baiti"/>
+        <a:font script="Viet" typeface="Arial"/>
+        <a:font script="Uigh" typeface="Microsoft Uighur"/>
+        <a:font script="Geor" typeface="Sylfaen"/>
+        <a:font script="Armn" typeface="Arial"/>
+        <a:font script="Bugi" typeface="Leelawadee UI"/>
+        <a:font script="Bopo" typeface="Microsoft JhengHei"/>
+        <a:font script="Java" typeface="Javanese Text"/>
+        <a:font script="Lisu" typeface="Segoe UI"/>
+        <a:font script="Mymr" typeface="Myanmar Text"/>
+        <a:font script="Nkoo" typeface="Ebrima"/>
+        <a:font script="Olck" typeface="Nirmala UI"/>
+        <a:font script="Osma" typeface="Ebrima"/>
+        <a:font script="Phag" typeface="Phagspa"/>
+        <a:font script="Syrn" typeface="Estrangelo Edessa"/>
+        <a:font script="Syrj" typeface="Estrangelo Edessa"/>
+        <a:font script="Syre" typeface="Estrangelo Edessa"/>
+        <a:font script="Sora" typeface="Nirmala UI"/>
+        <a:font script="Tale" typeface="Microsoft Tai Le"/>
+        <a:font script="Talu" typeface="Microsoft New Tai Lue"/>
+        <a:font script="Tfng" typeface="Ebrima"/>
+      </a:minorFont>
+    </a:fontScheme>
+    <a:fmtScheme name="Office">
+      <a:fillStyleLst>
+        <a:solidFill>
+          <a:schemeClr val="phClr"/>
+        </a:solidFill>
+        <a:gradFill rotWithShape="1">
+          <a:gsLst>
+            <a:gs pos="0">
+              <a:schemeClr val="phClr">
+                <a:lumMod val="110000"/>
+                <a:satMod val="105000"/>
+                <a:tint val="67000"/>
+              </a:schemeClr>
+            </a:gs>
+            <a:gs pos="50000">
+              <a:schemeClr val="phClr">
+                <a:lumMod val="105000"/>
+                <a:satMod val="103000"/>
+                <a:tint val="73000"/>
+              </a:schemeClr>
+            </a:gs>
+            <a:gs pos="100000">
+              <a:schemeClr val="phClr">
+                <a:lumMod val="105000"/>
+                <a:satMod val="109000"/>
+                <a:tint val="81000"/>
+              </a:schemeClr>
+            </a:gs>
+          </a:gsLst>
+          <a:lin ang="5400000" scaled="0"/>
+        </a:gradFill>
+        <a:gradFill rotWithShape="1">
+          <a:gsLst>
+            <a:gs pos="0">
+              <a:schemeClr val="phClr">
+                <a:satMod val="103000"/>
+                <a:lumMod val="102000"/>
+                <a:tint val="94000"/>
+              </a:schemeClr>
+            </a:gs>
+            <a:gs pos="50000">
+              <a:schemeClr val="phClr">
+                <a:satMod val="110000"/>
+                <a:lumMod val="100000"/>
+                <a:shade val="100000"/>
+              </a:schemeClr>
+            </a:gs>
+            <a:gs pos="100000">
+              <a:schemeClr val="phClr">
+                <a:lumMod val="99000"/>
+                <a:satMod val="120000"/>
+                <a:shade val="78000"/>
+              </a:schemeClr>
+            </a:gs>
+          </a:gsLst>
+          <a:lin ang="5400000" scaled="0"/>
+        </a:gradFill>
+      </a:fillStyleLst>
+      <a:lnStyleLst>
+        <a:ln w="12700" cap="flat" cmpd="sng" algn="ctr">
+          <a:solidFill>
+            <a:schemeClr val="phClr"/>
+          </a:solidFill>
+          <a:prstDash val="solid"/>
+          <a:miter lim="800000"/>
+        </a:ln>
+        <a:ln w="19050" cap="flat" cmpd="sng" algn="ctr">
+          <a:solidFill>
+            <a:schemeClr val="phClr"/>
+          </a:solidFill>
+          <a:prstDash val="solid"/>
+          <a:miter lim="800000"/>
+        </a:ln>
+        <a:ln w="25400" cap="flat" cmpd="sng" algn="ctr">
+          <a:solidFill>
+            <a:schemeClr val="phClr"/>
+          </a:solidFill>
+          <a:prstDash val="solid"/>
+          <a:miter lim="800000"/>
+        </a:ln>
+      </a:lnStyleLst>
+      <a:effectStyleLst>
+        <a:effectStyle>
+          <a:effectLst/>
+        </a:effectStyle>
+        <a:effectStyle>
+          <a:effectLst/>
+        </a:effectStyle>
+        <a:effectStyle>
+          <a:effectLst>
+            <a:outerShdw blurRad="57150" dist="19050" dir="5400000" algn="ctr" rotWithShape="0">
+              <a:srgbClr val="000000">
+                <a:alpha val="63000"/>
+              </a:srgbClr>
+            </a:outerShdw>
+          </a:effectLst>
+        </a:effectStyle>
+      </a:effectStyleLst>
+      <a:bgFillStyleLst>
+        <a:solidFill>
+          <a:schemeClr val="phClr"/>
+        </a:solidFill>
+        <a:solidFill>
+          <a:schemeClr val="phClr">
+            <a:tint val="95000"/>
+            <a:satMod val="170000"/>
+          </a:schemeClr>
+        </a:solidFill>
+        <a:gradFill rotWithShape="1">
+          <a:gsLst>
+            <a:gs pos="0">
+              <a:schemeClr val="phClr">
+                <a:tint val="93000"/>
+                <a:satMod val="150000"/>
+                <a:shade val="98000"/>
+                <a:lumMod val="102000"/>
+              </a:schemeClr>
+            </a:gs>
+            <a:gs pos="50000">
+              <a:schemeClr val="phClr">
+                <a:tint val="98000"/>
+                <a:satMod val="130000"/>
+                <a:shade val="90000"/>
+                <a:lumMod val="103000"/>
+              </a:schemeClr>
+            </a:gs>
+            <a:gs pos="100000">
+              <a:schemeClr val="phClr">
+                <a:shade val="63000"/>
+                <a:satMod val="120000"/>
+              </a:schemeClr>
+            </a:gs>
+          </a:gsLst>
+          <a:lin ang="5400000" scaled="0"/>
+        </a:gradFill>
+      </a:bgFillStyleLst>
+    </a:fmtScheme>
+  </a:themeElements>
+  <a:objectDefaults>
+    <a:lnDef>
+      <a:spPr/>
+      <a:bodyPr/>
+      <a:lstStyle/>
+      <a:style>
+        <a:lnRef idx="2">
+          <a:schemeClr val="accent1"/>
+        </a:lnRef>
+        <a:fillRef idx="0">
+          <a:schemeClr val="accent1"/>
+        </a:fillRef>
+        <a:effectRef idx="1">
+          <a:schemeClr val="accent1"/>
+        </a:effectRef>
+        <a:fontRef idx="minor">
+          <a:schemeClr val="tx1"/>
+        </a:fontRef>
+      </a:style>
+    </a:lnDef>
+  </a:objectDefaults>
+  <a:extraClrSchemeLst/>
+  <a:extLst>
+    <a:ext uri="{05A4C25C-085E-4340-85A3-A5531E510DB2}">
+      <thm15:themeFamily xmlns:thm15="http://schemas.microsoft.com/office/thememl/2012/main" name="Office Theme" id="{2E142A2C-CD16-42D6-873A-C26D2A0506FA}" vid="{1BDDFF52-6CD6-40A5-AB3C-68EB2F1E4D0A}"/>
+    </a:ext>
+  </a:extLst>
+</a:theme>
 </file>
</xml_diff>

<commit_message>
Adiciona os integrantes do grupo na capa da apresentacao
</commit_message>
<xml_diff>
--- a/reports/apresentacao_crescimento_receita.pptx
+++ b/reports/apresentacao_crescimento_receita.pptx
@@ -135,18 +135,18 @@
   <pc:docChgLst>
     <pc:chgData name="Evanio Carvalho" userId="a84c28dca2c48ebb" providerId="LiveId" clId="{9951D568-64CE-4441-9351-9161622AC723}"/>
     <pc:docChg chg="undo custSel modSld">
-      <pc:chgData name="Evanio Carvalho" userId="a84c28dca2c48ebb" providerId="LiveId" clId="{9951D568-64CE-4441-9351-9161622AC723}" dt="2026-08-20T01:32:39.784" v="87" actId="20577"/>
+      <pc:chgData name="Evanio Carvalho" userId="a84c28dca2c48ebb" providerId="LiveId" clId="{9951D568-64CE-4441-9351-9161622AC723}" dt="2026-08-20T01:51:33.418" v="91" actId="20577"/>
       <pc:docMkLst>
         <pc:docMk/>
       </pc:docMkLst>
       <pc:sldChg chg="modSp mod">
-        <pc:chgData name="Evanio Carvalho" userId="a84c28dca2c48ebb" providerId="LiveId" clId="{9951D568-64CE-4441-9351-9161622AC723}" dt="2026-08-20T01:30:39.089" v="86" actId="20577"/>
+        <pc:chgData name="Evanio Carvalho" userId="a84c28dca2c48ebb" providerId="LiveId" clId="{9951D568-64CE-4441-9351-9161622AC723}" dt="2026-08-20T01:51:33.418" v="91" actId="20577"/>
         <pc:sldMkLst>
           <pc:docMk/>
           <pc:sldMk cId="0" sldId="256"/>
         </pc:sldMkLst>
         <pc:spChg chg="mod">
-          <ac:chgData name="Evanio Carvalho" userId="a84c28dca2c48ebb" providerId="LiveId" clId="{9951D568-64CE-4441-9351-9161622AC723}" dt="2026-08-20T01:30:39.089" v="86" actId="20577"/>
+          <ac:chgData name="Evanio Carvalho" userId="a84c28dca2c48ebb" providerId="LiveId" clId="{9951D568-64CE-4441-9351-9161622AC723}" dt="2026-08-20T01:51:33.418" v="91" actId="20577"/>
           <ac:spMkLst>
             <pc:docMk/>
             <pc:sldMk cId="0" sldId="256"/>
@@ -2467,7 +2467,7 @@
                 <a:ea typeface="Calibri" pitchFamily="34" charset="-122"/>
                 <a:cs typeface="Calibri" pitchFamily="34" charset="-120"/>
               </a:rPr>
-              <a:t>Marcela Morillas de S</a:t>
+              <a:t>Marcela Morillas de Souza</a:t>
             </a:r>
           </a:p>
         </p:txBody>

</xml_diff>

<commit_message>
Ordena os integrantes alfabeticamente na apresentacao
</commit_message>
<xml_diff>
--- a/reports/apresentacao_crescimento_receita.pptx
+++ b/reports/apresentacao_crescimento_receita.pptx
@@ -2397,7 +2397,7 @@
                 <a:ea typeface="Calibri" pitchFamily="34" charset="-122"/>
                 <a:cs typeface="Calibri" pitchFamily="34" charset="-120"/>
               </a:rPr>
-              <a:t>Eduardo </a:t>
+              <a:t>Eduardo Zancanaro Vilela</a:t>
             </a:r>
             <a:r>
               <a:rPr lang="en-US" sz="1600" dirty="0" err="1">
@@ -2408,7 +2408,7 @@
                 <a:ea typeface="Calibri" pitchFamily="34" charset="-122"/>
                 <a:cs typeface="Calibri" pitchFamily="34" charset="-120"/>
               </a:rPr>
-              <a:t>Zancanaro</a:t>
+              <a:t/>
             </a:r>
             <a:r>
               <a:rPr lang="en-US" sz="1600" dirty="0">
@@ -2419,7 +2419,7 @@
                 <a:ea typeface="Calibri" pitchFamily="34" charset="-122"/>
                 <a:cs typeface="Calibri" pitchFamily="34" charset="-120"/>
               </a:rPr>
-              <a:t> Vilela</a:t>
+              <a:t/>
             </a:r>
           </a:p>
           <a:p>
@@ -2451,7 +2451,7 @@
                 <a:ea typeface="Calibri" pitchFamily="34" charset="-122"/>
                 <a:cs typeface="Calibri" pitchFamily="34" charset="-120"/>
               </a:rPr>
-              <a:t>Mateus Araujo </a:t>
+              <a:t>Marcela Morillas de Souza</a:t>
             </a:r>
           </a:p>
           <a:p>
@@ -2467,7 +2467,7 @@
                 <a:ea typeface="Calibri" pitchFamily="34" charset="-122"/>
                 <a:cs typeface="Calibri" pitchFamily="34" charset="-120"/>
               </a:rPr>
-              <a:t>Marcela Morillas de Souza</a:t>
+              <a:t>Mateus Araujo</a:t>
             </a:r>
           </a:p>
         </p:txBody>

</xml_diff>

<commit_message>
Corrige o uso de agosto de 2018, a afirmacao sobre a Black Friday e os pontos da revisao tecnica
</commit_message>
<xml_diff>
--- a/reports/apresentacao_crescimento_receita.pptx
+++ b/reports/apresentacao_crescimento_receita.pptx
@@ -6035,8 +6035,8 @@
         </p:blipFill>
         <p:spPr>
           <a:xfrm>
-            <a:off x="1874062" y="1024128"/>
-            <a:ext cx="8459114" cy="3845052"/>
+            <a:off x="2130552" y="1024128"/>
+            <a:ext cx="7946136" cy="3611880"/>
           </a:xfrm>
           <a:prstGeom prst="rect">
             <a:avLst/>
@@ -6051,8 +6051,8 @@
         </p:nvSpPr>
         <p:spPr>
           <a:xfrm>
-            <a:off x="548640" y="5070348"/>
-            <a:ext cx="11091672" cy="1092708"/>
+            <a:off x="548640" y="4837176"/>
+            <a:ext cx="11091672" cy="1325880"/>
           </a:xfrm>
           <a:prstGeom prst="rect">
             <a:avLst/>
@@ -6095,8 +6095,8 @@
         </p:nvSpPr>
         <p:spPr>
           <a:xfrm>
-            <a:off x="841248" y="5207508"/>
-            <a:ext cx="10506456" cy="854964"/>
+            <a:off x="841248" y="4974336"/>
+            <a:ext cx="10506456" cy="1088136"/>
           </a:xfrm>
           <a:prstGeom prst="rect">
             <a:avLst/>
@@ -6140,7 +6140,7 @@
                 </a:solidFill>
                 <a:latin typeface="Calibri"/>
               </a:rPr>
-              <a:t>O número importa menos que o recado: a projeção confirma o platô. Serve como referência, não como meta.</a:t>
+              <a:t>Agosto entra na média com o mês incompleto, então a projeção é conservadora. O número importa menos que o recado: ela confirma o platô e serve como referência, não como meta.</a:t>
             </a:r>
           </a:p>
         </p:txBody>
@@ -6566,7 +6566,7 @@
         </p:nvSpPr>
         <p:spPr>
           <a:xfrm>
-            <a:off x="548640" y="2295144"/>
+            <a:off x="548640" y="2141220"/>
             <a:ext cx="384048" cy="384048"/>
           </a:xfrm>
           <a:prstGeom prst="ellipse">
@@ -6610,7 +6610,7 @@
         </p:nvSpPr>
         <p:spPr>
           <a:xfrm>
-            <a:off x="548640" y="2295144"/>
+            <a:off x="548640" y="2141220"/>
             <a:ext cx="384048" cy="384048"/>
           </a:xfrm>
           <a:prstGeom prst="rect">
@@ -6649,7 +6649,7 @@
         </p:nvSpPr>
         <p:spPr>
           <a:xfrm>
-            <a:off x="1097280" y="2258568"/>
+            <a:off x="1097280" y="2104644"/>
             <a:ext cx="10515600" cy="274320"/>
           </a:xfrm>
           <a:prstGeom prst="rect">
@@ -6688,7 +6688,7 @@
         </p:nvSpPr>
         <p:spPr>
           <a:xfrm>
-            <a:off x="1097280" y="2569463"/>
+            <a:off x="1097280" y="2415540"/>
             <a:ext cx="10515600" cy="457200"/>
           </a:xfrm>
           <a:prstGeom prst="rect">
@@ -6727,7 +6727,7 @@
         </p:nvSpPr>
         <p:spPr>
           <a:xfrm>
-            <a:off x="548640" y="3218688"/>
+            <a:off x="548640" y="2910840"/>
             <a:ext cx="384048" cy="384048"/>
           </a:xfrm>
           <a:prstGeom prst="ellipse">
@@ -6771,7 +6771,7 @@
         </p:nvSpPr>
         <p:spPr>
           <a:xfrm>
-            <a:off x="548640" y="3218688"/>
+            <a:off x="548640" y="2910840"/>
             <a:ext cx="384048" cy="384048"/>
           </a:xfrm>
           <a:prstGeom prst="rect">
@@ -6810,7 +6810,7 @@
         </p:nvSpPr>
         <p:spPr>
           <a:xfrm>
-            <a:off x="1097280" y="3182112"/>
+            <a:off x="1097280" y="2874264"/>
             <a:ext cx="10515600" cy="274320"/>
           </a:xfrm>
           <a:prstGeom prst="rect">
@@ -6849,7 +6849,7 @@
         </p:nvSpPr>
         <p:spPr>
           <a:xfrm>
-            <a:off x="1097280" y="3493008"/>
+            <a:off x="1097280" y="3185160"/>
             <a:ext cx="10515600" cy="457200"/>
           </a:xfrm>
           <a:prstGeom prst="rect">
@@ -6888,7 +6888,7 @@
         </p:nvSpPr>
         <p:spPr>
           <a:xfrm>
-            <a:off x="548640" y="4142232"/>
+            <a:off x="548640" y="3680460"/>
             <a:ext cx="384048" cy="384048"/>
           </a:xfrm>
           <a:prstGeom prst="ellipse">
@@ -6932,7 +6932,7 @@
         </p:nvSpPr>
         <p:spPr>
           <a:xfrm>
-            <a:off x="548640" y="4142232"/>
+            <a:off x="548640" y="3680460"/>
             <a:ext cx="384048" cy="384048"/>
           </a:xfrm>
           <a:prstGeom prst="rect">
@@ -6971,7 +6971,7 @@
         </p:nvSpPr>
         <p:spPr>
           <a:xfrm>
-            <a:off x="1097280" y="4105656"/>
+            <a:off x="1097280" y="3643884"/>
             <a:ext cx="10515600" cy="274320"/>
           </a:xfrm>
           <a:prstGeom prst="rect">
@@ -6997,7 +6997,7 @@
                 </a:solidFill>
                 <a:latin typeface="Calibri"/>
               </a:rPr>
-              <a:t>Acompanhar a receita por vendedor</a:t>
+              <a:t>Acompanhar o valor por vendedor</a:t>
             </a:r>
           </a:p>
         </p:txBody>
@@ -7010,7 +7010,7 @@
         </p:nvSpPr>
         <p:spPr>
           <a:xfrm>
-            <a:off x="1097280" y="4416552"/>
+            <a:off x="1097280" y="3954780"/>
             <a:ext cx="10515600" cy="457200"/>
           </a:xfrm>
           <a:prstGeom prst="rect">
@@ -7049,7 +7049,7 @@
         </p:nvSpPr>
         <p:spPr>
           <a:xfrm>
-            <a:off x="548640" y="5065776"/>
+            <a:off x="548640" y="4450080"/>
             <a:ext cx="384048" cy="384048"/>
           </a:xfrm>
           <a:prstGeom prst="ellipse">
@@ -7093,7 +7093,7 @@
         </p:nvSpPr>
         <p:spPr>
           <a:xfrm>
-            <a:off x="548640" y="5065776"/>
+            <a:off x="548640" y="4450080"/>
             <a:ext cx="384048" cy="384048"/>
           </a:xfrm>
           <a:prstGeom prst="rect">
@@ -7132,7 +7132,7 @@
         </p:nvSpPr>
         <p:spPr>
           <a:xfrm>
-            <a:off x="1097280" y="5029200"/>
+            <a:off x="1097280" y="4413504"/>
             <a:ext cx="10515600" cy="274320"/>
           </a:xfrm>
           <a:prstGeom prst="rect">
@@ -7171,7 +7171,7 @@
         </p:nvSpPr>
         <p:spPr>
           <a:xfrm>
-            <a:off x="1097280" y="5340096"/>
+            <a:off x="1097280" y="4724400"/>
             <a:ext cx="10515600" cy="457200"/>
           </a:xfrm>
           <a:prstGeom prst="rect">
@@ -7198,6 +7198,167 @@
                 <a:latin typeface="Calibri"/>
               </a:rPr>
               <a:t>O crescimento veio de volume e não de ticket maior, o que deixa espaço para combos, kits e venda casada.</a:t>
+            </a:r>
+          </a:p>
+        </p:txBody>
+      </p:sp>
+      <p:sp>
+        <p:nvSpPr>
+          <p:cNvPr id="27" name="Oval 26"/>
+          <p:cNvSpPr/>
+          <p:nvPr/>
+        </p:nvSpPr>
+        <p:spPr>
+          <a:xfrm>
+            <a:off x="548640" y="5219700"/>
+            <a:ext cx="384048" cy="384048"/>
+          </a:xfrm>
+          <a:prstGeom prst="ellipse">
+            <a:avLst/>
+          </a:prstGeom>
+          <a:solidFill>
+            <a:srgbClr val="ED1064"/>
+          </a:solidFill>
+          <a:ln>
+            <a:noFill/>
+          </a:ln>
+          <a:effectLst/>
+        </p:spPr>
+        <p:style>
+          <a:lnRef idx="1">
+            <a:schemeClr val="accent1"/>
+          </a:lnRef>
+          <a:fillRef idx="3">
+            <a:schemeClr val="accent1"/>
+          </a:fillRef>
+          <a:effectRef idx="2">
+            <a:schemeClr val="accent1"/>
+          </a:effectRef>
+          <a:fontRef idx="minor">
+            <a:schemeClr val="lt1"/>
+          </a:fontRef>
+        </p:style>
+        <p:txBody>
+          <a:bodyPr rtlCol="0" anchor="ctr"/>
+          <a:lstStyle/>
+          <a:p>
+            <a:pPr algn="ctr"/>
+          </a:p>
+        </p:txBody>
+      </p:sp>
+      <p:sp>
+        <p:nvSpPr>
+          <p:cNvPr id="28" name="TextBox 27"/>
+          <p:cNvSpPr txBox="1"/>
+          <p:nvPr/>
+        </p:nvSpPr>
+        <p:spPr>
+          <a:xfrm>
+            <a:off x="548640" y="5219700"/>
+            <a:ext cx="384048" cy="384048"/>
+          </a:xfrm>
+          <a:prstGeom prst="rect">
+            <a:avLst/>
+          </a:prstGeom>
+          <a:noFill/>
+        </p:spPr>
+        <p:txBody>
+          <a:bodyPr wrap="square" anchor="ctr" lIns="0" rIns="0" tIns="0" bIns="0">
+            <a:spAutoFit/>
+          </a:bodyPr>
+          <a:lstStyle/>
+          <a:p>
+            <a:pPr algn="ctr">
+              <a:lnSpc>
+                <a:spcPct val="115000"/>
+              </a:lnSpc>
+            </a:pPr>
+            <a:r>
+              <a:rPr sz="1200" b="1">
+                <a:solidFill>
+                  <a:srgbClr val="FFFFFF"/>
+                </a:solidFill>
+                <a:latin typeface="Calibri"/>
+              </a:rPr>
+              <a:t>6</a:t>
+            </a:r>
+          </a:p>
+        </p:txBody>
+      </p:sp>
+      <p:sp>
+        <p:nvSpPr>
+          <p:cNvPr id="29" name="TextBox 28"/>
+          <p:cNvSpPr txBox="1"/>
+          <p:nvPr/>
+        </p:nvSpPr>
+        <p:spPr>
+          <a:xfrm>
+            <a:off x="1097280" y="5183124"/>
+            <a:ext cx="10515600" cy="274320"/>
+          </a:xfrm>
+          <a:prstGeom prst="rect">
+            <a:avLst/>
+          </a:prstGeom>
+          <a:noFill/>
+        </p:spPr>
+        <p:txBody>
+          <a:bodyPr wrap="square" anchor="t" lIns="0" rIns="0" tIns="0" bIns="0">
+            <a:spAutoFit/>
+          </a:bodyPr>
+          <a:lstStyle/>
+          <a:p>
+            <a:pPr algn="l">
+              <a:lnSpc>
+                <a:spcPct val="115000"/>
+              </a:lnSpc>
+            </a:pPr>
+            <a:r>
+              <a:rPr sz="1300" b="1">
+                <a:solidFill>
+                  <a:srgbClr val="1A1A1A"/>
+                </a:solidFill>
+                <a:latin typeface="Calibri"/>
+              </a:rPr>
+              <a:t>Não tratar o valor transacionado como receita da Olist</a:t>
+            </a:r>
+          </a:p>
+        </p:txBody>
+      </p:sp>
+      <p:sp>
+        <p:nvSpPr>
+          <p:cNvPr id="30" name="TextBox 29"/>
+          <p:cNvSpPr txBox="1"/>
+          <p:nvPr/>
+        </p:nvSpPr>
+        <p:spPr>
+          <a:xfrm>
+            <a:off x="1097280" y="5494020"/>
+            <a:ext cx="10515600" cy="457200"/>
+          </a:xfrm>
+          <a:prstGeom prst="rect">
+            <a:avLst/>
+          </a:prstGeom>
+          <a:noFill/>
+        </p:spPr>
+        <p:txBody>
+          <a:bodyPr wrap="square" anchor="t" lIns="0" rIns="0" tIns="0" bIns="0">
+            <a:spAutoFit/>
+          </a:bodyPr>
+          <a:lstStyle/>
+          <a:p>
+            <a:pPr algn="l">
+              <a:lnSpc>
+                <a:spcPct val="115000"/>
+              </a:lnSpc>
+            </a:pPr>
+            <a:r>
+              <a:rPr sz="1100" b="0">
+                <a:solidFill>
+                  <a:srgbClr val="6B6B6B"/>
+                </a:solidFill>
+                <a:latin typeface="Calibri"/>
+              </a:rPr>
+              <a:t>A base não informa a comissão. Antes de avaliar retorno, é preciso enriquecê-la com comissão, taxas e custo de aquisição.</a:t>
             </a:r>
           </a:p>
         </p:txBody>
@@ -7429,7 +7590,7 @@
                 </a:solidFill>
                 <a:latin typeface="Calibri"/>
               </a:rPr>
-              <a:t>Por isso, a receita analisada aqui é o valor total da venda e não o que entra no caixa da empresa.</a:t>
+              <a:t>O que este estudo chama de valor transacionado é preço dos itens mais frete, e não o que entra no caixa da empresa.</a:t>
             </a:r>
           </a:p>
           <a:p>
@@ -7552,7 +7713,7 @@
                 </a:solidFill>
                 <a:latin typeface="Calibri"/>
               </a:rPr>
-              <a:t>As conclusões se limitam a volume de vendas, receita e concentração.</a:t>
+              <a:t>As conclusões se limitam a volume de vendas, valor transacionado e concentração.</a:t>
             </a:r>
           </a:p>
         </p:txBody>
@@ -8923,7 +9084,7 @@
                 </a:solidFill>
                 <a:latin typeface="Calibri"/>
               </a:rPr>
-              <a:t>Tabela fato no grão de item de pedido, com dimensões de cliente, produto, vendedor e data.</a:t>
+              <a:t>Tabela fato no grão de item de pedido, com dimensões de cliente, produto e vendedor.</a:t>
             </a:r>
           </a:p>
         </p:txBody>
@@ -8936,7 +9097,7 @@
         </p:nvSpPr>
         <p:spPr>
           <a:xfrm>
-            <a:off x="548640" y="2295144"/>
+            <a:off x="548640" y="2141220"/>
             <a:ext cx="384048" cy="384048"/>
           </a:xfrm>
           <a:prstGeom prst="ellipse">
@@ -8980,7 +9141,7 @@
         </p:nvSpPr>
         <p:spPr>
           <a:xfrm>
-            <a:off x="548640" y="2295144"/>
+            <a:off x="548640" y="2141220"/>
             <a:ext cx="384048" cy="384048"/>
           </a:xfrm>
           <a:prstGeom prst="rect">
@@ -9019,7 +9180,7 @@
         </p:nvSpPr>
         <p:spPr>
           <a:xfrm>
-            <a:off x="1097280" y="2258568"/>
+            <a:off x="1097280" y="2104644"/>
             <a:ext cx="10515600" cy="274320"/>
           </a:xfrm>
           <a:prstGeom prst="rect">
@@ -9058,7 +9219,7 @@
         </p:nvSpPr>
         <p:spPr>
           <a:xfrm>
-            <a:off x="1097280" y="2569463"/>
+            <a:off x="1097280" y="2415540"/>
             <a:ext cx="10515600" cy="457200"/>
           </a:xfrm>
           <a:prstGeom prst="rect">
@@ -9097,7 +9258,7 @@
         </p:nvSpPr>
         <p:spPr>
           <a:xfrm>
-            <a:off x="548640" y="3218688"/>
+            <a:off x="548640" y="2910840"/>
             <a:ext cx="384048" cy="384048"/>
           </a:xfrm>
           <a:prstGeom prst="ellipse">
@@ -9141,7 +9302,7 @@
         </p:nvSpPr>
         <p:spPr>
           <a:xfrm>
-            <a:off x="548640" y="3218688"/>
+            <a:off x="548640" y="2910840"/>
             <a:ext cx="384048" cy="384048"/>
           </a:xfrm>
           <a:prstGeom prst="rect">
@@ -9180,7 +9341,7 @@
         </p:nvSpPr>
         <p:spPr>
           <a:xfrm>
-            <a:off x="1097280" y="3182112"/>
+            <a:off x="1097280" y="2874264"/>
             <a:ext cx="10515600" cy="274320"/>
           </a:xfrm>
           <a:prstGeom prst="rect">
@@ -9219,7 +9380,7 @@
         </p:nvSpPr>
         <p:spPr>
           <a:xfrm>
-            <a:off x="1097280" y="3493008"/>
+            <a:off x="1097280" y="3185160"/>
             <a:ext cx="10515600" cy="457200"/>
           </a:xfrm>
           <a:prstGeom prst="rect">
@@ -9258,7 +9419,7 @@
         </p:nvSpPr>
         <p:spPr>
           <a:xfrm>
-            <a:off x="548640" y="4142232"/>
+            <a:off x="548640" y="3680460"/>
             <a:ext cx="384048" cy="384048"/>
           </a:xfrm>
           <a:prstGeom prst="ellipse">
@@ -9302,7 +9463,7 @@
         </p:nvSpPr>
         <p:spPr>
           <a:xfrm>
-            <a:off x="548640" y="4142232"/>
+            <a:off x="548640" y="3680460"/>
             <a:ext cx="384048" cy="384048"/>
           </a:xfrm>
           <a:prstGeom prst="rect">
@@ -9341,7 +9502,7 @@
         </p:nvSpPr>
         <p:spPr>
           <a:xfrm>
-            <a:off x="1097280" y="4105656"/>
+            <a:off x="1097280" y="3643884"/>
             <a:ext cx="10515600" cy="274320"/>
           </a:xfrm>
           <a:prstGeom prst="rect">
@@ -9380,7 +9541,7 @@
         </p:nvSpPr>
         <p:spPr>
           <a:xfrm>
-            <a:off x="1097280" y="4416552"/>
+            <a:off x="1097280" y="3954780"/>
             <a:ext cx="10515600" cy="457200"/>
           </a:xfrm>
           <a:prstGeom prst="rect">
@@ -9419,7 +9580,7 @@
         </p:nvSpPr>
         <p:spPr>
           <a:xfrm>
-            <a:off x="548640" y="5065776"/>
+            <a:off x="548640" y="4450080"/>
             <a:ext cx="384048" cy="384048"/>
           </a:xfrm>
           <a:prstGeom prst="ellipse">
@@ -9463,7 +9624,7 @@
         </p:nvSpPr>
         <p:spPr>
           <a:xfrm>
-            <a:off x="548640" y="5065776"/>
+            <a:off x="548640" y="4450080"/>
             <a:ext cx="384048" cy="384048"/>
           </a:xfrm>
           <a:prstGeom prst="rect">
@@ -9502,7 +9663,7 @@
         </p:nvSpPr>
         <p:spPr>
           <a:xfrm>
-            <a:off x="1097280" y="5029200"/>
+            <a:off x="1097280" y="4413504"/>
             <a:ext cx="10515600" cy="274320"/>
           </a:xfrm>
           <a:prstGeom prst="rect">
@@ -9541,7 +9702,7 @@
         </p:nvSpPr>
         <p:spPr>
           <a:xfrm>
-            <a:off x="1097280" y="5340096"/>
+            <a:off x="1097280" y="4724400"/>
             <a:ext cx="10515600" cy="457200"/>
           </a:xfrm>
           <a:prstGeom prst="rect">
@@ -9568,6 +9729,167 @@
                 <a:latin typeface="Calibri"/>
               </a:rPr>
               <a:t>São produtos caros reais e não erros de cadastro. A assimetria é tratada reportando a mediana.</a:t>
+            </a:r>
+          </a:p>
+        </p:txBody>
+      </p:sp>
+      <p:sp>
+        <p:nvSpPr>
+          <p:cNvPr id="27" name="Oval 26"/>
+          <p:cNvSpPr/>
+          <p:nvPr/>
+        </p:nvSpPr>
+        <p:spPr>
+          <a:xfrm>
+            <a:off x="548640" y="5219700"/>
+            <a:ext cx="384048" cy="384048"/>
+          </a:xfrm>
+          <a:prstGeom prst="ellipse">
+            <a:avLst/>
+          </a:prstGeom>
+          <a:solidFill>
+            <a:srgbClr val="ED1064"/>
+          </a:solidFill>
+          <a:ln>
+            <a:noFill/>
+          </a:ln>
+          <a:effectLst/>
+        </p:spPr>
+        <p:style>
+          <a:lnRef idx="1">
+            <a:schemeClr val="accent1"/>
+          </a:lnRef>
+          <a:fillRef idx="3">
+            <a:schemeClr val="accent1"/>
+          </a:fillRef>
+          <a:effectRef idx="2">
+            <a:schemeClr val="accent1"/>
+          </a:effectRef>
+          <a:fontRef idx="minor">
+            <a:schemeClr val="lt1"/>
+          </a:fontRef>
+        </p:style>
+        <p:txBody>
+          <a:bodyPr rtlCol="0" anchor="ctr"/>
+          <a:lstStyle/>
+          <a:p>
+            <a:pPr algn="ctr"/>
+          </a:p>
+        </p:txBody>
+      </p:sp>
+      <p:sp>
+        <p:nvSpPr>
+          <p:cNvPr id="28" name="TextBox 27"/>
+          <p:cNvSpPr txBox="1"/>
+          <p:nvPr/>
+        </p:nvSpPr>
+        <p:spPr>
+          <a:xfrm>
+            <a:off x="548640" y="5219700"/>
+            <a:ext cx="384048" cy="384048"/>
+          </a:xfrm>
+          <a:prstGeom prst="rect">
+            <a:avLst/>
+          </a:prstGeom>
+          <a:noFill/>
+        </p:spPr>
+        <p:txBody>
+          <a:bodyPr wrap="square" anchor="ctr" lIns="0" rIns="0" tIns="0" bIns="0">
+            <a:spAutoFit/>
+          </a:bodyPr>
+          <a:lstStyle/>
+          <a:p>
+            <a:pPr algn="ctr">
+              <a:lnSpc>
+                <a:spcPct val="115000"/>
+              </a:lnSpc>
+            </a:pPr>
+            <a:r>
+              <a:rPr sz="1200" b="1">
+                <a:solidFill>
+                  <a:srgbClr val="FFFFFF"/>
+                </a:solidFill>
+                <a:latin typeface="Calibri"/>
+              </a:rPr>
+              <a:t>6</a:t>
+            </a:r>
+          </a:p>
+        </p:txBody>
+      </p:sp>
+      <p:sp>
+        <p:nvSpPr>
+          <p:cNvPr id="29" name="TextBox 28"/>
+          <p:cNvSpPr txBox="1"/>
+          <p:nvPr/>
+        </p:nvSpPr>
+        <p:spPr>
+          <a:xfrm>
+            <a:off x="1097280" y="5183124"/>
+            <a:ext cx="10515600" cy="274320"/>
+          </a:xfrm>
+          <a:prstGeom prst="rect">
+            <a:avLst/>
+          </a:prstGeom>
+          <a:noFill/>
+        </p:spPr>
+        <p:txBody>
+          <a:bodyPr wrap="square" anchor="t" lIns="0" rIns="0" tIns="0" bIns="0">
+            <a:spAutoFit/>
+          </a:bodyPr>
+          <a:lstStyle/>
+          <a:p>
+            <a:pPr algn="l">
+              <a:lnSpc>
+                <a:spcPct val="115000"/>
+              </a:lnSpc>
+            </a:pPr>
+            <a:r>
+              <a:rPr sz="1300" b="1">
+                <a:solidFill>
+                  <a:srgbClr val="1A1A1A"/>
+                </a:solidFill>
+                <a:latin typeface="Calibri"/>
+              </a:rPr>
+              <a:t>Agosto de 2018 é parcial</a:t>
+            </a:r>
+          </a:p>
+        </p:txBody>
+      </p:sp>
+      <p:sp>
+        <p:nvSpPr>
+          <p:cNvPr id="30" name="TextBox 29"/>
+          <p:cNvSpPr txBox="1"/>
+          <p:nvPr/>
+        </p:nvSpPr>
+        <p:spPr>
+          <a:xfrm>
+            <a:off x="1097280" y="5494020"/>
+            <a:ext cx="10515600" cy="457200"/>
+          </a:xfrm>
+          <a:prstGeom prst="rect">
+            <a:avLst/>
+          </a:prstGeom>
+          <a:noFill/>
+        </p:spPr>
+        <p:txBody>
+          <a:bodyPr wrap="square" anchor="t" lIns="0" rIns="0" tIns="0" bIns="0">
+            <a:spAutoFit/>
+          </a:bodyPr>
+          <a:lstStyle/>
+          <a:p>
+            <a:pPr algn="l">
+              <a:lnSpc>
+                <a:spcPct val="115000"/>
+              </a:lnSpc>
+            </a:pPr>
+            <a:r>
+              <a:rPr sz="1100" b="0">
+                <a:solidFill>
+                  <a:srgbClr val="6B6B6B"/>
+                </a:solidFill>
+                <a:latin typeface="Calibri"/>
+              </a:rPr>
+              <a:t>A coleta para no dia 29. O mês fica no recorte, mas as comparações de 2018 usam janeiro e julho, que são fechados.</a:t>
             </a:r>
           </a:p>
         </p:txBody>
@@ -9863,7 +10185,7 @@
                 </a:solidFill>
                 <a:latin typeface="Calibri"/>
               </a:rPr>
-              <a:t>Receita total</a:t>
+              <a:t>Valor transacionado</a:t>
             </a:r>
           </a:p>
         </p:txBody>
@@ -10512,7 +10834,7 @@
                 </a:solidFill>
                 <a:latin typeface="Calibri"/>
               </a:rPr>
-              <a:t>Entre janeiro de 2017 e agosto de 2018.</a:t>
+              <a:t>Entre janeiro de 2017 e agosto de 2018. Valor transacionado é preço dos itens mais frete, não a comissão da Olist.</a:t>
             </a:r>
           </a:p>
         </p:txBody>
@@ -11490,7 +11812,7 @@
                 </a:solidFill>
                 <a:latin typeface="Calibri"/>
               </a:rPr>
-              <a:t>O maior mês da série é uma data promocional e não um novo patamar de vendas. Absorver esse pico sem ruptura, por outro lado, é um ponto positivo da plataforma.</a:t>
+              <a:t>O maior mês da série é uma data promocional e não um novo patamar de vendas. A plataforma absorveu o volume, mas com custo: quem comprou naquele fim de semana atrasou em 18,3% dos casos, contra 6,8% da média do período.</a:t>
             </a:r>
           </a:p>
         </p:txBody>
@@ -12149,7 +12471,7 @@
                 </a:solidFill>
                 <a:latin typeface="Calibri"/>
               </a:rPr>
-              <a:t>Em 2018 os vendedores ativos subiram de 968 para 1.266, um crescimento de 31%. Os clientes fizeram o contrário: caíram de 7.088 para 6.380, uma queda de 10%.</a:t>
+              <a:t>Entre janeiro e julho de 2018, os dois meses fechados que delimitam o ano na base, os vendedores ativos subiram de 968 para 1.245, um crescimento de 28,6%. Os clientes fizeram o contrário: caíram de 7.088 para 6.172, uma queda de 12,9%.</a:t>
             </a:r>
           </a:p>
           <a:p>
@@ -12168,7 +12490,7 @@
                 </a:solidFill>
                 <a:latin typeface="Calibri"/>
               </a:rPr>
-              <a:t>Com isso a receita por vendedor caiu 31%, de R$ 1.138 para R$ 787. O gargalo não é falta de quem venda, é falta de quem compre.</a:t>
+              <a:t>Com isso o valor por vendedor caiu 26,6%, de R$ 1.138 para R$ 835. O gargalo não é falta de quem venda, é falta de quem compre.</a:t>
             </a:r>
           </a:p>
         </p:txBody>

</xml_diff>

<commit_message>
Ajusta precisao de linguagem: frete nos demais estados, escopo do crescimento de 628%, e significancia estatistica da recompra
</commit_message>
<xml_diff>
--- a/reports/apresentacao_crescimento_receita.pptx
+++ b/reports/apresentacao_crescimento_receita.pptx
@@ -5008,7 +5008,7 @@
                 </a:solidFill>
                 <a:latin typeface="Calibri"/>
               </a:rPr>
-              <a:t>Os outros 22 esperam 17,3 dias e pagam quase o dobro de frete em proporção ao produto.</a:t>
+              <a:t>Os outros 22 esperam 17,3 dias e pagam mais frete em proporção ao produto, chegando a mais de 26% em MA e RR.</a:t>
             </a:r>
           </a:p>
           <a:p>
@@ -5763,7 +5763,7 @@
                 </a:solidFill>
                 <a:latin typeface="Calibri"/>
               </a:rPr>
-              <a:t>Queda de 22,6%, e o teste confirma que não é acaso (p = 0,007).</a:t>
+              <a:t>Queda de 22,6%, associação estatisticamente significativa (p = 0,007).</a:t>
             </a:r>
           </a:p>
           <a:p>

</xml_diff>